<commit_message>
Add universal bacteria slides to KAN2M3 v2 deck
Two slides after the species results: coverage by bacterial phylum for
the 15-probe universal set (95.3% of SILVA bacteria) and a table of the
probes with coverage and BLAST specificity.

Co-Authored-By: Claude Opus 5.5 <noreply@anthropic.com>
</commit_message>
<xml_diff>
--- a/KAN2M3/KAN2M3_probe_design_v2.pptx
+++ b/KAN2M3/KAN2M3_probe_design_v2.pptx
@@ -18,6 +18,8 @@
     <p:sldId id="266" r:id="rId18"/>
     <p:sldId id="267" r:id="rId19"/>
     <p:sldId id="268" r:id="rId20"/>
+    <p:sldId id="269" r:id="rId21"/>
+    <p:sldId id="270" r:id="rId22"/>
   </p:sldIdLst>
   <p:sldSz cx="12191695" cy="6858000" type="screen4x3"/>
   <p:notesSz cx="6858000" cy="9144000"/>
@@ -2186,6 +2188,541 @@
 <c:chartSpace xmlns:c="http://schemas.openxmlformats.org/drawingml/2006/chart" xmlns:a="http://schemas.openxmlformats.org/drawingml/2006/main" xmlns:r="http://schemas.openxmlformats.org/officeDocument/2006/relationships">
   <c:date1904 val="0"/>
   <c:chart>
+    <c:autoTitleDeleted val="1"/>
+    <c:plotArea>
+      <c:barChart>
+        <c:barDir val="bar"/>
+        <c:grouping val="clustered"/>
+        <c:ser>
+          <c:idx val="0"/>
+          <c:order val="0"/>
+          <c:tx>
+            <c:strRef>
+              <c:f>Sheet1!$B$1</c:f>
+              <c:strCache>
+                <c:ptCount val="1"/>
+                <c:pt idx="0">
+                  <c:v>Pooled coverage (%)</c:v>
+                </c:pt>
+              </c:strCache>
+            </c:strRef>
+          </c:tx>
+          <c:dPt>
+            <c:idx val="0"/>
+            <c:spPr>
+              <a:solidFill>
+                <a:srgbClr val="1B7F7A"/>
+              </a:solidFill>
+            </c:spPr>
+          </c:dPt>
+          <c:dPt>
+            <c:idx val="1"/>
+            <c:spPr>
+              <a:solidFill>
+                <a:srgbClr val="1B7F7A"/>
+              </a:solidFill>
+            </c:spPr>
+          </c:dPt>
+          <c:dPt>
+            <c:idx val="2"/>
+            <c:spPr>
+              <a:solidFill>
+                <a:srgbClr val="1B7F7A"/>
+              </a:solidFill>
+            </c:spPr>
+          </c:dPt>
+          <c:dPt>
+            <c:idx val="3"/>
+            <c:spPr>
+              <a:solidFill>
+                <a:srgbClr val="1B7F7A"/>
+              </a:solidFill>
+            </c:spPr>
+          </c:dPt>
+          <c:dPt>
+            <c:idx val="4"/>
+            <c:spPr>
+              <a:solidFill>
+                <a:srgbClr val="1B7F7A"/>
+              </a:solidFill>
+            </c:spPr>
+          </c:dPt>
+          <c:dPt>
+            <c:idx val="5"/>
+            <c:spPr>
+              <a:solidFill>
+                <a:srgbClr val="1B7F7A"/>
+              </a:solidFill>
+            </c:spPr>
+          </c:dPt>
+          <c:dPt>
+            <c:idx val="6"/>
+            <c:spPr>
+              <a:solidFill>
+                <a:srgbClr val="1B7F7A"/>
+              </a:solidFill>
+            </c:spPr>
+          </c:dPt>
+          <c:dPt>
+            <c:idx val="7"/>
+            <c:spPr>
+              <a:solidFill>
+                <a:srgbClr val="1B7F7A"/>
+              </a:solidFill>
+            </c:spPr>
+          </c:dPt>
+          <c:dPt>
+            <c:idx val="8"/>
+            <c:spPr>
+              <a:solidFill>
+                <a:srgbClr val="1B7F7A"/>
+              </a:solidFill>
+            </c:spPr>
+          </c:dPt>
+          <c:dPt>
+            <c:idx val="9"/>
+            <c:spPr>
+              <a:solidFill>
+                <a:srgbClr val="1B7F7A"/>
+              </a:solidFill>
+            </c:spPr>
+          </c:dPt>
+          <c:dPt>
+            <c:idx val="10"/>
+            <c:spPr>
+              <a:solidFill>
+                <a:srgbClr val="1B7F7A"/>
+              </a:solidFill>
+            </c:spPr>
+          </c:dPt>
+          <c:dPt>
+            <c:idx val="11"/>
+            <c:spPr>
+              <a:solidFill>
+                <a:srgbClr val="1B7F7A"/>
+              </a:solidFill>
+            </c:spPr>
+          </c:dPt>
+          <c:dPt>
+            <c:idx val="12"/>
+            <c:spPr>
+              <a:solidFill>
+                <a:srgbClr val="1B7F7A"/>
+              </a:solidFill>
+            </c:spPr>
+          </c:dPt>
+          <c:dPt>
+            <c:idx val="13"/>
+            <c:spPr>
+              <a:solidFill>
+                <a:srgbClr val="1B7F7A"/>
+              </a:solidFill>
+            </c:spPr>
+          </c:dPt>
+          <c:dPt>
+            <c:idx val="14"/>
+            <c:spPr>
+              <a:solidFill>
+                <a:srgbClr val="1B7F7A"/>
+              </a:solidFill>
+            </c:spPr>
+          </c:dPt>
+          <c:dPt>
+            <c:idx val="15"/>
+            <c:spPr>
+              <a:solidFill>
+                <a:srgbClr val="1B7F7A"/>
+              </a:solidFill>
+            </c:spPr>
+          </c:dPt>
+          <c:dPt>
+            <c:idx val="16"/>
+            <c:spPr>
+              <a:solidFill>
+                <a:srgbClr val="1B7F7A"/>
+              </a:solidFill>
+            </c:spPr>
+          </c:dPt>
+          <c:dPt>
+            <c:idx val="17"/>
+            <c:spPr>
+              <a:solidFill>
+                <a:srgbClr val="1B7F7A"/>
+              </a:solidFill>
+            </c:spPr>
+          </c:dPt>
+          <c:dPt>
+            <c:idx val="18"/>
+            <c:spPr>
+              <a:solidFill>
+                <a:srgbClr val="1B7F7A"/>
+              </a:solidFill>
+            </c:spPr>
+          </c:dPt>
+          <c:dPt>
+            <c:idx val="19"/>
+            <c:spPr>
+              <a:solidFill>
+                <a:srgbClr val="1B7F7A"/>
+              </a:solidFill>
+            </c:spPr>
+          </c:dPt>
+          <c:dPt>
+            <c:idx val="20"/>
+            <c:spPr>
+              <a:solidFill>
+                <a:srgbClr val="1B7F7A"/>
+              </a:solidFill>
+            </c:spPr>
+          </c:dPt>
+          <c:dPt>
+            <c:idx val="21"/>
+            <c:spPr>
+              <a:solidFill>
+                <a:srgbClr val="F0634F"/>
+              </a:solidFill>
+            </c:spPr>
+          </c:dPt>
+          <c:dPt>
+            <c:idx val="22"/>
+            <c:spPr>
+              <a:solidFill>
+                <a:srgbClr val="F0634F"/>
+              </a:solidFill>
+            </c:spPr>
+          </c:dPt>
+          <c:dPt>
+            <c:idx val="23"/>
+            <c:spPr>
+              <a:solidFill>
+                <a:srgbClr val="F0634F"/>
+              </a:solidFill>
+            </c:spPr>
+          </c:dPt>
+          <c:dPt>
+            <c:idx val="24"/>
+            <c:spPr>
+              <a:solidFill>
+                <a:srgbClr val="F0634F"/>
+              </a:solidFill>
+            </c:spPr>
+          </c:dPt>
+          <c:dPt>
+            <c:idx val="25"/>
+            <c:spPr>
+              <a:solidFill>
+                <a:srgbClr val="F0634F"/>
+              </a:solidFill>
+            </c:spPr>
+          </c:dPt>
+          <c:cat>
+            <c:strRef>
+              <c:f>Sheet1!$A$2:$A$27</c:f>
+              <c:strCache>
+                <c:ptCount val="26"/>
+                <c:pt idx="0">
+                  <c:v>SAR324 clade(Marine group B)</c:v>
+                </c:pt>
+                <c:pt idx="1">
+                  <c:v>Myxococcota</c:v>
+                </c:pt>
+                <c:pt idx="2">
+                  <c:v>Gemmatimonadota</c:v>
+                </c:pt>
+                <c:pt idx="3">
+                  <c:v>Synergistota</c:v>
+                </c:pt>
+                <c:pt idx="4">
+                  <c:v>Acidobacteriota</c:v>
+                </c:pt>
+                <c:pt idx="5">
+                  <c:v>Actinobacteriota</c:v>
+                </c:pt>
+                <c:pt idx="6">
+                  <c:v>Campylobacterota</c:v>
+                </c:pt>
+                <c:pt idx="7">
+                  <c:v>Firmicutes</c:v>
+                </c:pt>
+                <c:pt idx="8">
+                  <c:v>Desulfobacterota</c:v>
+                </c:pt>
+                <c:pt idx="9">
+                  <c:v>Nitrospirota</c:v>
+                </c:pt>
+                <c:pt idx="10">
+                  <c:v>Marinimicrobia (SAR406 clade)</c:v>
+                </c:pt>
+                <c:pt idx="11">
+                  <c:v>Deinococcota</c:v>
+                </c:pt>
+                <c:pt idx="12">
+                  <c:v>Bdellovibrionota</c:v>
+                </c:pt>
+                <c:pt idx="13">
+                  <c:v>Proteobacteria</c:v>
+                </c:pt>
+                <c:pt idx="14">
+                  <c:v>Fusobacteriota</c:v>
+                </c:pt>
+                <c:pt idx="15">
+                  <c:v>Spirochaetota</c:v>
+                </c:pt>
+                <c:pt idx="16">
+                  <c:v>Bacteroidota</c:v>
+                </c:pt>
+                <c:pt idx="17">
+                  <c:v>Latescibacterota</c:v>
+                </c:pt>
+                <c:pt idx="18">
+                  <c:v>Dependentiae</c:v>
+                </c:pt>
+                <c:pt idx="19">
+                  <c:v>Fibrobacterota</c:v>
+                </c:pt>
+                <c:pt idx="20">
+                  <c:v>Armatimonadota</c:v>
+                </c:pt>
+                <c:pt idx="21">
+                  <c:v>Cyanobacteria</c:v>
+                </c:pt>
+                <c:pt idx="22">
+                  <c:v>Verrucomicrobiota</c:v>
+                </c:pt>
+                <c:pt idx="23">
+                  <c:v>Chloroflexi</c:v>
+                </c:pt>
+                <c:pt idx="24">
+                  <c:v>Patescibacteria</c:v>
+                </c:pt>
+                <c:pt idx="25">
+                  <c:v>Planctomycetota</c:v>
+                </c:pt>
+              </c:strCache>
+            </c:strRef>
+          </c:cat>
+          <c:val>
+            <c:numRef>
+              <c:f>Sheet1!$B$2:$B$27</c:f>
+              <c:numCache>
+                <c:formatCode>General</c:formatCode>
+                <c:ptCount val="26"/>
+                <c:pt idx="0">
+                  <c:v>100.0</c:v>
+                </c:pt>
+                <c:pt idx="1">
+                  <c:v>100.0</c:v>
+                </c:pt>
+                <c:pt idx="2">
+                  <c:v>100.0</c:v>
+                </c:pt>
+                <c:pt idx="3">
+                  <c:v>99.9</c:v>
+                </c:pt>
+                <c:pt idx="4">
+                  <c:v>99.7</c:v>
+                </c:pt>
+                <c:pt idx="5">
+                  <c:v>99.7</c:v>
+                </c:pt>
+                <c:pt idx="6">
+                  <c:v>99.7</c:v>
+                </c:pt>
+                <c:pt idx="7">
+                  <c:v>99.6</c:v>
+                </c:pt>
+                <c:pt idx="8">
+                  <c:v>99.5</c:v>
+                </c:pt>
+                <c:pt idx="9">
+                  <c:v>99.4</c:v>
+                </c:pt>
+                <c:pt idx="10">
+                  <c:v>99.2</c:v>
+                </c:pt>
+                <c:pt idx="11">
+                  <c:v>99.2</c:v>
+                </c:pt>
+                <c:pt idx="12">
+                  <c:v>98.9</c:v>
+                </c:pt>
+                <c:pt idx="13">
+                  <c:v>98.9</c:v>
+                </c:pt>
+                <c:pt idx="14">
+                  <c:v>98.2</c:v>
+                </c:pt>
+                <c:pt idx="15">
+                  <c:v>97.5</c:v>
+                </c:pt>
+                <c:pt idx="16">
+                  <c:v>96.7</c:v>
+                </c:pt>
+                <c:pt idx="17">
+                  <c:v>95.8</c:v>
+                </c:pt>
+                <c:pt idx="18">
+                  <c:v>95.4</c:v>
+                </c:pt>
+                <c:pt idx="19">
+                  <c:v>95.2</c:v>
+                </c:pt>
+                <c:pt idx="20">
+                  <c:v>92.7</c:v>
+                </c:pt>
+                <c:pt idx="21">
+                  <c:v>87.8</c:v>
+                </c:pt>
+                <c:pt idx="22">
+                  <c:v>79.2</c:v>
+                </c:pt>
+                <c:pt idx="23">
+                  <c:v>70.0</c:v>
+                </c:pt>
+                <c:pt idx="24">
+                  <c:v>24.2</c:v>
+                </c:pt>
+                <c:pt idx="25">
+                  <c:v>21.1</c:v>
+                </c:pt>
+              </c:numCache>
+            </c:numRef>
+          </c:val>
+        </c:ser>
+        <c:dLbls>
+          <c:numFmt formatCode="0&quot;%&quot;" sourceLinked="0"/>
+          <c:txPr>
+            <a:bodyPr/>
+            <a:lstStyle/>
+            <a:p>
+              <a:pPr>
+                <a:defRPr sz="800">
+                  <a:solidFill>
+                    <a:srgbClr val="1F2A30"/>
+                  </a:solidFill>
+                </a:defRPr>
+              </a:pPr>
+            </a:p>
+          </c:txPr>
+          <c:dLblPos val="outEnd"/>
+          <c:showLegendKey val="0"/>
+          <c:showVal val="1"/>
+          <c:showCatName val="0"/>
+          <c:showSerName val="0"/>
+          <c:showPercent val="0"/>
+          <c:showBubbleSize val="0"/>
+          <c:showLeaderLines val="1"/>
+        </c:dLbls>
+        <c:gapWidth val="45"/>
+        <c:axId val="-2068027336"/>
+        <c:axId val="-2113994440"/>
+      </c:barChart>
+      <c:catAx>
+        <c:axId val="-2068027336"/>
+        <c:scaling>
+          <c:orientation val="maxMin"/>
+        </c:scaling>
+        <c:delete val="0"/>
+        <c:axPos val="l"/>
+        <c:majorTickMark val="out"/>
+        <c:minorTickMark val="none"/>
+        <c:tickLblPos val="nextTo"/>
+        <c:spPr>
+          <a:ln>
+            <a:solidFill>
+              <a:srgbClr val="D9E2E1"/>
+            </a:solidFill>
+          </a:ln>
+        </c:spPr>
+        <c:txPr>
+          <a:bodyPr/>
+          <a:lstStyle/>
+          <a:p>
+            <a:pPr>
+              <a:defRPr sz="800">
+                <a:solidFill>
+                  <a:srgbClr val="1F2A30"/>
+                </a:solidFill>
+              </a:defRPr>
+            </a:pPr>
+          </a:p>
+        </c:txPr>
+        <c:crossAx val="-2113994440"/>
+        <c:crosses val="autoZero"/>
+        <c:auto val="1"/>
+        <c:lblAlgn val="ctr"/>
+        <c:lblOffset val="100"/>
+        <c:tickLblSkip val="1"/>
+        <c:noMultiLvlLbl val="0"/>
+      </c:catAx>
+      <c:valAx>
+        <c:axId val="-2113994440"/>
+        <c:scaling>
+          <c:max val="100.0"/>
+          <c:min val="0.0"/>
+        </c:scaling>
+        <c:delete val="0"/>
+        <c:axPos val="b"/>
+        <c:majorGridlines>
+          <c:spPr>
+            <a:ln>
+              <a:solidFill>
+                <a:srgbClr val="D9E2E1"/>
+              </a:solidFill>
+            </a:ln>
+          </c:spPr>
+        </c:majorGridlines>
+        <c:numFmt formatCode="0&quot;%&quot;" sourceLinked="0"/>
+        <c:majorTickMark val="out"/>
+        <c:minorTickMark val="none"/>
+        <c:tickLblPos val="nextTo"/>
+        <c:spPr>
+          <a:ln>
+            <a:noFill/>
+          </a:ln>
+        </c:spPr>
+        <c:txPr>
+          <a:bodyPr/>
+          <a:lstStyle/>
+          <a:p>
+            <a:pPr>
+              <a:defRPr sz="900">
+                <a:solidFill>
+                  <a:srgbClr val="5F6B70"/>
+                </a:solidFill>
+              </a:defRPr>
+            </a:pPr>
+          </a:p>
+        </c:txPr>
+        <c:crossAx val="-2068027336"/>
+        <c:crosses val="autoZero"/>
+        <c:majorUnit val="25.0"/>
+      </c:valAx>
+    </c:plotArea>
+    <c:dispBlanksAs val="gap"/>
+  </c:chart>
+  <c:txPr>
+    <a:bodyPr/>
+    <a:lstStyle/>
+    <a:p>
+      <a:pPr>
+        <a:defRPr sz="1800">
+          <a:latin typeface="Arial"/>
+        </a:defRPr>
+      </a:pPr>
+      <a:endParaRPr lang="en-US"/>
+    </a:p>
+  </c:txPr>
+  <c:externalData r:id="rId1">
+    <c:autoUpdate val="0"/>
+  </c:externalData>
+</c:chartSpace>
+</file>
+
+<file path=ppt/charts/chart7.xml><?xml version="1.0" encoding="utf-8"?>
+<c:chartSpace xmlns:c="http://schemas.openxmlformats.org/drawingml/2006/chart" xmlns:a="http://schemas.openxmlformats.org/drawingml/2006/main" xmlns:r="http://schemas.openxmlformats.org/officeDocument/2006/relationships">
+  <c:date1904 val="0"/>
+  <c:chart>
     <c:title>
       <c:tx>
         <c:rich>
@@ -3078,7 +3615,7 @@
           <a:lstStyle/>
           <a:p>
             <a:r>
-              <a:t>Strains and subspecies count as the target species. Most probes match few SILVA sequences exactly but near-match almost all, suggesting they come from one reference strain.</a:t>
+              <a:t>One pooled set aimed at every bacterium. Coverage is near-complete for the phyla that dominate host-associated samples; the gaps are environmental phyla with divergent 16S genes.</a:t>
             </a:r>
           </a:p>
         </p:txBody>
@@ -3104,6 +3641,146 @@
 </file>
 
 <file path=ppt/notesSlides/notesSlide13.xml><?xml version="1.0" encoding="utf-8"?>
+<p:notes xmlns:a="http://schemas.openxmlformats.org/drawingml/2006/main" xmlns:p="http://schemas.openxmlformats.org/presentationml/2006/main" xmlns:r="http://schemas.openxmlformats.org/officeDocument/2006/relationships">
+  <p:cSld>
+    <p:spTree>
+      <p:nvGrpSpPr>
+        <p:cNvPr id="1" name=""/>
+        <p:cNvGrpSpPr/>
+        <p:nvPr/>
+      </p:nvGrpSpPr>
+      <p:grpSpPr>
+        <a:xfrm>
+          <a:off x="0" y="0"/>
+          <a:ext cx="0" cy="0"/>
+          <a:chOff x="0" y="0"/>
+          <a:chExt cx="0" cy="0"/>
+        </a:xfrm>
+      </p:grpSpPr>
+      <p:sp>
+        <p:nvSpPr>
+          <p:cNvPr id="2" name="Slide Image Placeholder 1"/>
+          <p:cNvSpPr>
+            <a:spLocks noGrp="1"/>
+          </p:cNvSpPr>
+          <p:nvPr>
+            <p:ph type="sldImg" idx="2"/>
+          </p:nvPr>
+        </p:nvSpPr>
+        <p:spPr/>
+      </p:sp>
+      <p:sp>
+        <p:nvSpPr>
+          <p:cNvPr id="3" name="Notes Placeholder 2"/>
+          <p:cNvSpPr>
+            <a:spLocks noGrp="1"/>
+          </p:cNvSpPr>
+          <p:nvPr>
+            <p:ph type="body" idx="3" sz="quarter"/>
+          </p:nvPr>
+        </p:nvSpPr>
+        <p:spPr/>
+        <p:txBody>
+          <a:bodyPr/>
+          <a:lstStyle/>
+          <a:p>
+            <a:r>
+              <a:t>Probe 6 contains the classic universal probe EUB338 (GCTGCCTCCCGTAGGAGT). Several probes are variants of the same site for different groups; they never occur on the same sequence.</a:t>
+            </a:r>
+          </a:p>
+        </p:txBody>
+      </p:sp>
+      <p:sp>
+        <p:nvSpPr>
+          <p:cNvPr id="4" name="Slide Number Placeholder 3"/>
+          <p:cNvSpPr>
+            <a:spLocks noGrp="1"/>
+          </p:cNvSpPr>
+          <p:nvPr>
+            <p:ph type="sldNum" idx="5" sz="quarter"/>
+          </p:nvPr>
+        </p:nvSpPr>
+        <p:spPr/>
+      </p:sp>
+    </p:spTree>
+  </p:cSld>
+  <p:clrMapOvr>
+    <a:masterClrMapping/>
+  </p:clrMapOvr>
+</p:notes>
+</file>
+
+<file path=ppt/notesSlides/notesSlide14.xml><?xml version="1.0" encoding="utf-8"?>
+<p:notes xmlns:a="http://schemas.openxmlformats.org/drawingml/2006/main" xmlns:p="http://schemas.openxmlformats.org/presentationml/2006/main" xmlns:r="http://schemas.openxmlformats.org/officeDocument/2006/relationships">
+  <p:cSld>
+    <p:spTree>
+      <p:nvGrpSpPr>
+        <p:cNvPr id="1" name=""/>
+        <p:cNvGrpSpPr/>
+        <p:nvPr/>
+      </p:nvGrpSpPr>
+      <p:grpSpPr>
+        <a:xfrm>
+          <a:off x="0" y="0"/>
+          <a:ext cx="0" cy="0"/>
+          <a:chOff x="0" y="0"/>
+          <a:chExt cx="0" cy="0"/>
+        </a:xfrm>
+      </p:grpSpPr>
+      <p:sp>
+        <p:nvSpPr>
+          <p:cNvPr id="2" name="Slide Image Placeholder 1"/>
+          <p:cNvSpPr>
+            <a:spLocks noGrp="1"/>
+          </p:cNvSpPr>
+          <p:nvPr>
+            <p:ph type="sldImg" idx="2"/>
+          </p:nvPr>
+        </p:nvSpPr>
+        <p:spPr/>
+      </p:sp>
+      <p:sp>
+        <p:nvSpPr>
+          <p:cNvPr id="3" name="Notes Placeholder 2"/>
+          <p:cNvSpPr>
+            <a:spLocks noGrp="1"/>
+          </p:cNvSpPr>
+          <p:nvPr>
+            <p:ph type="body" idx="3" sz="quarter"/>
+          </p:nvPr>
+        </p:nvSpPr>
+        <p:spPr/>
+        <p:txBody>
+          <a:bodyPr/>
+          <a:lstStyle/>
+          <a:p>
+            <a:r>
+              <a:t>Strains and subspecies count as the target species. Most probes match few SILVA sequences exactly but near-match almost all, suggesting they come from one reference strain.</a:t>
+            </a:r>
+          </a:p>
+        </p:txBody>
+      </p:sp>
+      <p:sp>
+        <p:nvSpPr>
+          <p:cNvPr id="4" name="Slide Number Placeholder 3"/>
+          <p:cNvSpPr>
+            <a:spLocks noGrp="1"/>
+          </p:cNvSpPr>
+          <p:nvPr>
+            <p:ph type="sldNum" idx="5" sz="quarter"/>
+          </p:nvPr>
+        </p:nvSpPr>
+        <p:spPr/>
+      </p:sp>
+    </p:spTree>
+  </p:cSld>
+  <p:clrMapOvr>
+    <a:masterClrMapping/>
+  </p:clrMapOvr>
+</p:notes>
+</file>
+
+<file path=ppt/notesSlides/notesSlide15.xml><?xml version="1.0" encoding="utf-8"?>
 <p:notes xmlns:a="http://schemas.openxmlformats.org/drawingml/2006/main" xmlns:p="http://schemas.openxmlformats.org/presentationml/2006/main" xmlns:r="http://schemas.openxmlformats.org/officeDocument/2006/relationships">
   <p:cSld>
     <p:spTree>
@@ -9098,7 +9775,7 @@
                 </a:solidFill>
                 <a:latin typeface="Arial"/>
               </a:rPr>
-              <a:t>Validation: 35 external probes, no exact off-targets</a:t>
+              <a:t>Universal bacteria: 15 probes cover 95% of all bacteria</a:t>
             </a:r>
           </a:p>
         </p:txBody>
@@ -9137,7 +9814,7 @@
                 </a:solidFill>
                 <a:latin typeface="Arial"/>
               </a:rPr>
-              <a:t>bac-probes validate --blast --exclude-unnamed-congeners on the KAN2M3 query probes (40-mers, 7 species)</a:t>
+              <a:t>Target: domain Bacteria (431,575 sequences)  ·  BLAST  ·  probes on the same molecule ≥ 10 bp apart  ·  off-targets: Archaea and Eukaryota</a:t>
             </a:r>
           </a:p>
         </p:txBody>
@@ -9300,7 +9977,7 @@
                 </a:solidFill>
                 <a:latin typeface="Arial"/>
               </a:rPr>
-              <a:t>0</a:t>
+              <a:t>95.3%</a:t>
             </a:r>
           </a:p>
         </p:txBody>
@@ -9339,7 +10016,7 @@
                 </a:solidFill>
                 <a:latin typeface="Arial"/>
               </a:rPr>
-              <a:t>exact off-target matches across all 35 probes</a:t>
+              <a:t>of all bacterial 16S sequences in SILVA</a:t>
             </a:r>
           </a:p>
         </p:txBody>
@@ -9420,11 +10097,11 @@
             <a:r>
               <a:rPr sz="3600" b="1" i="0">
                 <a:solidFill>
-                  <a:srgbClr val="F0634F"/>
+                  <a:srgbClr val="0B3C49"/>
                 </a:solidFill>
                 <a:latin typeface="Arial"/>
               </a:rPr>
-              <a:t>31 / 35</a:t>
+              <a:t>15</a:t>
             </a:r>
           </a:p>
         </p:txBody>
@@ -9463,7 +10140,7 @@
                 </a:solidFill>
                 <a:latin typeface="Arial"/>
               </a:rPr>
-              <a:t>probes exactly match &lt; 5% of their species</a:t>
+              <a:t>probes, at least 10 bp apart on shared sequences</a:t>
             </a:r>
           </a:p>
         </p:txBody>
@@ -9548,6 +10225,3235 @@
                 </a:solidFill>
                 <a:latin typeface="Arial"/>
               </a:rPr>
+              <a:t>≥ 0.9999</a:t>
+            </a:r>
+          </a:p>
+        </p:txBody>
+      </p:sp>
+      <p:sp>
+        <p:nvSpPr>
+          <p:cNvPr id="14" name="TextBox 13"/>
+          <p:cNvSpPr txBox="1"/>
+          <p:nvPr/>
+        </p:nvSpPr>
+        <p:spPr>
+          <a:xfrm>
+            <a:off x="777240" y="5577840"/>
+            <a:ext cx="2560320" cy="411479"/>
+          </a:xfrm>
+          <a:prstGeom prst="rect">
+            <a:avLst/>
+          </a:prstGeom>
+          <a:noFill/>
+        </p:spPr>
+        <p:txBody>
+          <a:bodyPr wrap="square" anchor="t" lIns="0" rIns="0" tIns="0" bIns="0">
+            <a:spAutoFit/>
+          </a:bodyPr>
+          <a:lstStyle/>
+          <a:p>
+            <a:pPr algn="l">
+              <a:spcAft>
+                <a:spcPts val="0"/>
+              </a:spcAft>
+            </a:pPr>
+            <a:r>
+              <a:rPr sz="1200" b="0" i="0">
+                <a:solidFill>
+                  <a:srgbClr val="1F2A30"/>
+                </a:solidFill>
+                <a:latin typeface="Arial"/>
+              </a:rPr>
+              <a:t>BLAST weighted specificity for every probe</a:t>
+            </a:r>
+          </a:p>
+        </p:txBody>
+      </p:sp>
+      <p:graphicFrame>
+        <p:nvGraphicFramePr>
+          <p:cNvPr id="15" name="Chart 14"/>
+          <p:cNvGraphicFramePr>
+            <a:graphicFrameLocks noGrp="1"/>
+          </p:cNvGraphicFramePr>
+          <p:nvPr/>
+        </p:nvGraphicFramePr>
+        <p:xfrm>
+          <a:off x="3886200" y="1417320"/>
+          <a:ext cx="7772400" cy="4709160"/>
+        </p:xfrm>
+        <a:graphic>
+          <a:graphicData uri="http://schemas.openxmlformats.org/drawingml/2006/chart">
+            <c:chart xmlns:c="http://schemas.openxmlformats.org/drawingml/2006/chart" r:id="rId3"/>
+          </a:graphicData>
+        </a:graphic>
+      </p:graphicFrame>
+      <p:sp>
+        <p:nvSpPr>
+          <p:cNvPr id="16" name="Rectangle 15"/>
+          <p:cNvSpPr/>
+          <p:nvPr/>
+        </p:nvSpPr>
+        <p:spPr>
+          <a:xfrm>
+            <a:off x="4023360" y="6181344"/>
+            <a:ext cx="146304" cy="146304"/>
+          </a:xfrm>
+          <a:prstGeom prst="rect">
+            <a:avLst/>
+          </a:prstGeom>
+          <a:solidFill>
+            <a:srgbClr val="1B7F7A"/>
+          </a:solidFill>
+          <a:ln>
+            <a:noFill/>
+          </a:ln>
+          <a:effectLst/>
+        </p:spPr>
+        <p:style>
+          <a:lnRef idx="1">
+            <a:schemeClr val="accent1"/>
+          </a:lnRef>
+          <a:fillRef idx="3">
+            <a:schemeClr val="accent1"/>
+          </a:fillRef>
+          <a:effectRef idx="2">
+            <a:schemeClr val="accent1"/>
+          </a:effectRef>
+          <a:fontRef idx="minor">
+            <a:schemeClr val="lt1"/>
+          </a:fontRef>
+        </p:style>
+        <p:txBody>
+          <a:bodyPr rtlCol="0" anchor="ctr"/>
+          <a:lstStyle/>
+          <a:p>
+            <a:pPr algn="ctr"/>
+          </a:p>
+        </p:txBody>
+      </p:sp>
+      <p:sp>
+        <p:nvSpPr>
+          <p:cNvPr id="17" name="TextBox 16"/>
+          <p:cNvSpPr txBox="1"/>
+          <p:nvPr/>
+        </p:nvSpPr>
+        <p:spPr>
+          <a:xfrm>
+            <a:off x="4242816" y="6144768"/>
+            <a:ext cx="1737360" cy="228600"/>
+          </a:xfrm>
+          <a:prstGeom prst="rect">
+            <a:avLst/>
+          </a:prstGeom>
+          <a:noFill/>
+        </p:spPr>
+        <p:txBody>
+          <a:bodyPr wrap="square" anchor="t" lIns="0" rIns="0" tIns="0" bIns="0">
+            <a:spAutoFit/>
+          </a:bodyPr>
+          <a:lstStyle/>
+          <a:p>
+            <a:pPr algn="l">
+              <a:spcAft>
+                <a:spcPts val="0"/>
+              </a:spcAft>
+            </a:pPr>
+            <a:r>
+              <a:rPr sz="1000" b="0" i="0">
+                <a:solidFill>
+                  <a:srgbClr val="5F6B70"/>
+                </a:solidFill>
+                <a:latin typeface="Arial"/>
+              </a:rPr>
+              <a:t>≥ 90% of the phylum</a:t>
+            </a:r>
+          </a:p>
+        </p:txBody>
+      </p:sp>
+      <p:sp>
+        <p:nvSpPr>
+          <p:cNvPr id="18" name="Rectangle 17"/>
+          <p:cNvSpPr/>
+          <p:nvPr/>
+        </p:nvSpPr>
+        <p:spPr>
+          <a:xfrm>
+            <a:off x="5852160" y="6181344"/>
+            <a:ext cx="146304" cy="146304"/>
+          </a:xfrm>
+          <a:prstGeom prst="rect">
+            <a:avLst/>
+          </a:prstGeom>
+          <a:solidFill>
+            <a:srgbClr val="F0634F"/>
+          </a:solidFill>
+          <a:ln>
+            <a:noFill/>
+          </a:ln>
+          <a:effectLst/>
+        </p:spPr>
+        <p:style>
+          <a:lnRef idx="1">
+            <a:schemeClr val="accent1"/>
+          </a:lnRef>
+          <a:fillRef idx="3">
+            <a:schemeClr val="accent1"/>
+          </a:fillRef>
+          <a:effectRef idx="2">
+            <a:schemeClr val="accent1"/>
+          </a:effectRef>
+          <a:fontRef idx="minor">
+            <a:schemeClr val="lt1"/>
+          </a:fontRef>
+        </p:style>
+        <p:txBody>
+          <a:bodyPr rtlCol="0" anchor="ctr"/>
+          <a:lstStyle/>
+          <a:p>
+            <a:pPr algn="ctr"/>
+          </a:p>
+        </p:txBody>
+      </p:sp>
+      <p:sp>
+        <p:nvSpPr>
+          <p:cNvPr id="19" name="TextBox 18"/>
+          <p:cNvSpPr txBox="1"/>
+          <p:nvPr/>
+        </p:nvSpPr>
+        <p:spPr>
+          <a:xfrm>
+            <a:off x="6071616" y="6144768"/>
+            <a:ext cx="1737360" cy="228600"/>
+          </a:xfrm>
+          <a:prstGeom prst="rect">
+            <a:avLst/>
+          </a:prstGeom>
+          <a:noFill/>
+        </p:spPr>
+        <p:txBody>
+          <a:bodyPr wrap="square" anchor="t" lIns="0" rIns="0" tIns="0" bIns="0">
+            <a:spAutoFit/>
+          </a:bodyPr>
+          <a:lstStyle/>
+          <a:p>
+            <a:pPr algn="l">
+              <a:spcAft>
+                <a:spcPts val="0"/>
+              </a:spcAft>
+            </a:pPr>
+            <a:r>
+              <a:rPr sz="1000" b="0" i="0">
+                <a:solidFill>
+                  <a:srgbClr val="5F6B70"/>
+                </a:solidFill>
+                <a:latin typeface="Arial"/>
+              </a:rPr>
+              <a:t>&lt; 90% of the phylum</a:t>
+            </a:r>
+          </a:p>
+        </p:txBody>
+      </p:sp>
+    </p:spTree>
+  </p:cSld>
+  <p:clrMapOvr>
+    <a:masterClrMapping/>
+  </p:clrMapOvr>
+</p:sld>
+</file>
+
+<file path=ppt/slides/slide13.xml><?xml version="1.0" encoding="utf-8"?>
+<p:sld xmlns:a="http://schemas.openxmlformats.org/drawingml/2006/main" xmlns:p="http://schemas.openxmlformats.org/presentationml/2006/main" xmlns:r="http://schemas.openxmlformats.org/officeDocument/2006/relationships">
+  <p:cSld>
+    <p:bg>
+      <p:bgPr>
+        <a:solidFill>
+          <a:srgbClr val="FFFFFF"/>
+        </a:solidFill>
+        <a:effectLst/>
+      </p:bgPr>
+    </p:bg>
+    <p:spTree>
+      <p:nvGrpSpPr>
+        <p:cNvPr id="1" name=""/>
+        <p:cNvGrpSpPr/>
+        <p:nvPr/>
+      </p:nvGrpSpPr>
+      <p:grpSpPr/>
+      <p:sp>
+        <p:nvSpPr>
+          <p:cNvPr id="2" name="Title"/>
+          <p:cNvSpPr txBox="1"/>
+          <p:nvPr/>
+        </p:nvSpPr>
+        <p:spPr>
+          <a:xfrm>
+            <a:off x="548640" y="384048"/>
+            <a:ext cx="11064240" cy="640080"/>
+          </a:xfrm>
+          <a:prstGeom prst="rect">
+            <a:avLst/>
+          </a:prstGeom>
+          <a:noFill/>
+        </p:spPr>
+        <p:txBody>
+          <a:bodyPr wrap="square" anchor="t" lIns="0" rIns="0" tIns="0" bIns="0">
+            <a:spAutoFit/>
+          </a:bodyPr>
+          <a:lstStyle/>
+          <a:p>
+            <a:pPr algn="l">
+              <a:spcAft>
+                <a:spcPts val="0"/>
+              </a:spcAft>
+            </a:pPr>
+            <a:r>
+              <a:rPr sz="3000" b="1" i="0">
+                <a:solidFill>
+                  <a:srgbClr val="0B3C49"/>
+                </a:solidFill>
+                <a:latin typeface="Arial"/>
+              </a:rPr>
+              <a:t>Universal bacteria: the probe set</a:t>
+            </a:r>
+          </a:p>
+        </p:txBody>
+      </p:sp>
+      <p:sp>
+        <p:nvSpPr>
+          <p:cNvPr id="3" name="Subtitle"/>
+          <p:cNvSpPr txBox="1"/>
+          <p:nvPr/>
+        </p:nvSpPr>
+        <p:spPr>
+          <a:xfrm>
+            <a:off x="548640" y="987552"/>
+            <a:ext cx="11064240" cy="365760"/>
+          </a:xfrm>
+          <a:prstGeom prst="rect">
+            <a:avLst/>
+          </a:prstGeom>
+          <a:noFill/>
+        </p:spPr>
+        <p:txBody>
+          <a:bodyPr wrap="square" anchor="t" lIns="0" rIns="0" tIns="0" bIns="0">
+            <a:spAutoFit/>
+          </a:bodyPr>
+          <a:lstStyle/>
+          <a:p>
+            <a:pPr algn="l">
+              <a:spcAft>
+                <a:spcPts val="0"/>
+              </a:spcAft>
+            </a:pPr>
+            <a:r>
+              <a:rPr sz="1400" b="0" i="0">
+                <a:solidFill>
+                  <a:srgbClr val="5F6B70"/>
+                </a:solidFill>
+                <a:latin typeface="Arial"/>
+              </a:rPr>
+              <a:t>Probe = sequence to order  ·  Alone = share of all bacteria it matches exactly  ·  Cumulative = pooled coverage in pick order</a:t>
+            </a:r>
+          </a:p>
+        </p:txBody>
+      </p:sp>
+      <p:sp>
+        <p:nvSpPr>
+          <p:cNvPr id="4" name="TextBox 3"/>
+          <p:cNvSpPr txBox="1"/>
+          <p:nvPr/>
+        </p:nvSpPr>
+        <p:spPr>
+          <a:xfrm>
+            <a:off x="548640" y="6446520"/>
+            <a:ext cx="7315200" cy="228600"/>
+          </a:xfrm>
+          <a:prstGeom prst="rect">
+            <a:avLst/>
+          </a:prstGeom>
+          <a:noFill/>
+        </p:spPr>
+        <p:txBody>
+          <a:bodyPr wrap="square" anchor="t" lIns="0" rIns="0" tIns="0" bIns="0">
+            <a:spAutoFit/>
+          </a:bodyPr>
+          <a:lstStyle/>
+          <a:p>
+            <a:pPr algn="l">
+              <a:spcAft>
+                <a:spcPts val="0"/>
+              </a:spcAft>
+            </a:pPr>
+            <a:r>
+              <a:rPr sz="900" b="0" i="0">
+                <a:solidFill>
+                  <a:srgbClr val="5F6B70"/>
+                </a:solidFill>
+                <a:latin typeface="Arial"/>
+              </a:rPr>
+              <a:t>bac-probes  ·  KAN2M3 probe design</a:t>
+            </a:r>
+          </a:p>
+        </p:txBody>
+      </p:sp>
+      <p:sp>
+        <p:nvSpPr>
+          <p:cNvPr id="5" name="TextBox 4"/>
+          <p:cNvSpPr txBox="1"/>
+          <p:nvPr/>
+        </p:nvSpPr>
+        <p:spPr>
+          <a:xfrm>
+            <a:off x="10725912" y="6446520"/>
+            <a:ext cx="914400" cy="228600"/>
+          </a:xfrm>
+          <a:prstGeom prst="rect">
+            <a:avLst/>
+          </a:prstGeom>
+          <a:noFill/>
+        </p:spPr>
+        <p:txBody>
+          <a:bodyPr wrap="square" anchor="t" lIns="0" rIns="0" tIns="0" bIns="0">
+            <a:spAutoFit/>
+          </a:bodyPr>
+          <a:lstStyle/>
+          <a:p>
+            <a:pPr algn="r">
+              <a:spcAft>
+                <a:spcPts val="0"/>
+              </a:spcAft>
+            </a:pPr>
+            <a:r>
+              <a:rPr sz="900" b="0" i="0">
+                <a:solidFill>
+                  <a:srgbClr val="5F6B70"/>
+                </a:solidFill>
+                <a:latin typeface="Arial"/>
+              </a:rPr>
+              <a:t>13</a:t>
+            </a:r>
+          </a:p>
+        </p:txBody>
+      </p:sp>
+      <p:graphicFrame>
+        <p:nvGraphicFramePr>
+          <p:cNvPr id="6" name="Table 5"/>
+          <p:cNvGraphicFramePr>
+            <a:graphicFrameLocks noGrp="1"/>
+          </p:cNvGraphicFramePr>
+          <p:nvPr/>
+        </p:nvGraphicFramePr>
+        <p:xfrm>
+          <a:off x="548640" y="1508760"/>
+          <a:ext cx="11064240" cy="4535424"/>
+        </p:xfrm>
+        <a:graphic>
+          <a:graphicData uri="http://schemas.openxmlformats.org/drawingml/2006/table">
+            <a:tbl>
+              <a:tblPr firstRow="1">
+                <a:tableStyleId>{5C22544A-7EE6-4342-B048-85BDC9FD1C3A}</a:tableStyleId>
+              </a:tblPr>
+              <a:tblGrid>
+                <a:gridCol w="640080"/>
+                <a:gridCol w="5120640"/>
+                <a:gridCol w="1280160"/>
+                <a:gridCol w="1554480"/>
+                <a:gridCol w="1188720"/>
+                <a:gridCol w="1280160"/>
+              </a:tblGrid>
+              <a:tr h="283464">
+                <a:tc>
+                  <a:txBody>
+                    <a:bodyPr wrap="square"/>
+                    <a:lstStyle/>
+                    <a:p>
+                      <a:pPr algn="ctr"/>
+                      <a:r>
+                        <a:rPr sz="1100" b="1">
+                          <a:solidFill>
+                            <a:srgbClr val="FFFFFF"/>
+                          </a:solidFill>
+                          <a:latin typeface="Arial"/>
+                        </a:rPr>
+                        <a:t>#</a:t>
+                      </a:r>
+                    </a:p>
+                  </a:txBody>
+                  <a:tcPr marL="73152" marR="73152" marT="18288" marB="18288" anchor="ctr">
+                    <a:solidFill>
+                      <a:srgbClr val="0B3C49"/>
+                    </a:solidFill>
+                  </a:tcPr>
+                </a:tc>
+                <a:tc>
+                  <a:txBody>
+                    <a:bodyPr wrap="square"/>
+                    <a:lstStyle/>
+                    <a:p>
+                      <a:pPr algn="l"/>
+                      <a:r>
+                        <a:rPr sz="1100" b="1">
+                          <a:solidFill>
+                            <a:srgbClr val="FFFFFF"/>
+                          </a:solidFill>
+                          <a:latin typeface="Arial"/>
+                        </a:rPr>
+                        <a:t>Probe (order this)</a:t>
+                      </a:r>
+                    </a:p>
+                  </a:txBody>
+                  <a:tcPr marL="73152" marR="73152" marT="18288" marB="18288" anchor="ctr">
+                    <a:solidFill>
+                      <a:srgbClr val="0B3C49"/>
+                    </a:solidFill>
+                  </a:tcPr>
+                </a:tc>
+                <a:tc>
+                  <a:txBody>
+                    <a:bodyPr wrap="square"/>
+                    <a:lstStyle/>
+                    <a:p>
+                      <a:pPr algn="r"/>
+                      <a:r>
+                        <a:rPr sz="1100" b="1">
+                          <a:solidFill>
+                            <a:srgbClr val="FFFFFF"/>
+                          </a:solidFill>
+                          <a:latin typeface="Arial"/>
+                        </a:rPr>
+                        <a:t>Alone</a:t>
+                      </a:r>
+                    </a:p>
+                  </a:txBody>
+                  <a:tcPr marL="73152" marR="73152" marT="18288" marB="18288" anchor="ctr">
+                    <a:solidFill>
+                      <a:srgbClr val="0B3C49"/>
+                    </a:solidFill>
+                  </a:tcPr>
+                </a:tc>
+                <a:tc>
+                  <a:txBody>
+                    <a:bodyPr wrap="square"/>
+                    <a:lstStyle/>
+                    <a:p>
+                      <a:pPr algn="r"/>
+                      <a:r>
+                        <a:rPr sz="1100" b="1">
+                          <a:solidFill>
+                            <a:srgbClr val="FFFFFF"/>
+                          </a:solidFill>
+                          <a:latin typeface="Arial"/>
+                        </a:rPr>
+                        <a:t>Cumulative</a:t>
+                      </a:r>
+                    </a:p>
+                  </a:txBody>
+                  <a:tcPr marL="73152" marR="73152" marT="18288" marB="18288" anchor="ctr">
+                    <a:solidFill>
+                      <a:srgbClr val="0B3C49"/>
+                    </a:solidFill>
+                  </a:tcPr>
+                </a:tc>
+                <a:tc>
+                  <a:txBody>
+                    <a:bodyPr wrap="square"/>
+                    <a:lstStyle/>
+                    <a:p>
+                      <a:pPr algn="r"/>
+                      <a:r>
+                        <a:rPr sz="1100" b="1">
+                          <a:solidFill>
+                            <a:srgbClr val="FFFFFF"/>
+                          </a:solidFill>
+                          <a:latin typeface="Arial"/>
+                        </a:rPr>
+                        <a:t>Exact off</a:t>
+                      </a:r>
+                    </a:p>
+                  </a:txBody>
+                  <a:tcPr marL="73152" marR="73152" marT="18288" marB="18288" anchor="ctr">
+                    <a:solidFill>
+                      <a:srgbClr val="0B3C49"/>
+                    </a:solidFill>
+                  </a:tcPr>
+                </a:tc>
+                <a:tc>
+                  <a:txBody>
+                    <a:bodyPr wrap="square"/>
+                    <a:lstStyle/>
+                    <a:p>
+                      <a:pPr algn="r"/>
+                      <a:r>
+                        <a:rPr sz="1100" b="1">
+                          <a:solidFill>
+                            <a:srgbClr val="FFFFFF"/>
+                          </a:solidFill>
+                          <a:latin typeface="Arial"/>
+                        </a:rPr>
+                        <a:t>BLAST spec.</a:t>
+                      </a:r>
+                    </a:p>
+                  </a:txBody>
+                  <a:tcPr marL="73152" marR="73152" marT="18288" marB="18288" anchor="ctr">
+                    <a:solidFill>
+                      <a:srgbClr val="0B3C49"/>
+                    </a:solidFill>
+                  </a:tcPr>
+                </a:tc>
+              </a:tr>
+              <a:tr h="283464">
+                <a:tc>
+                  <a:txBody>
+                    <a:bodyPr wrap="square"/>
+                    <a:lstStyle/>
+                    <a:p>
+                      <a:pPr algn="ctr"/>
+                      <a:r>
+                        <a:rPr sz="1100" b="0">
+                          <a:solidFill>
+                            <a:srgbClr val="1F2A30"/>
+                          </a:solidFill>
+                          <a:latin typeface="Arial"/>
+                        </a:rPr>
+                        <a:t>1</a:t>
+                      </a:r>
+                    </a:p>
+                  </a:txBody>
+                  <a:tcPr marL="73152" marR="73152" marT="18288" marB="18288" anchor="ctr">
+                    <a:solidFill>
+                      <a:srgbClr val="FFFFFF"/>
+                    </a:solidFill>
+                  </a:tcPr>
+                </a:tc>
+                <a:tc>
+                  <a:txBody>
+                    <a:bodyPr wrap="square"/>
+                    <a:lstStyle/>
+                    <a:p>
+                      <a:pPr algn="l"/>
+                      <a:r>
+                        <a:rPr sz="1100" b="0">
+                          <a:solidFill>
+                            <a:srgbClr val="1F2A30"/>
+                          </a:solidFill>
+                          <a:latin typeface="Courier New"/>
+                        </a:rPr>
+                        <a:t>GGGTTGCGCTCGTTGCGGGACTTAACCCAACA</a:t>
+                      </a:r>
+                    </a:p>
+                  </a:txBody>
+                  <a:tcPr marL="73152" marR="73152" marT="18288" marB="18288" anchor="ctr">
+                    <a:solidFill>
+                      <a:srgbClr val="FFFFFF"/>
+                    </a:solidFill>
+                  </a:tcPr>
+                </a:tc>
+                <a:tc>
+                  <a:txBody>
+                    <a:bodyPr wrap="square"/>
+                    <a:lstStyle/>
+                    <a:p>
+                      <a:pPr algn="r"/>
+                      <a:r>
+                        <a:rPr sz="1100" b="0">
+                          <a:solidFill>
+                            <a:srgbClr val="1F2A30"/>
+                          </a:solidFill>
+                          <a:latin typeface="Arial"/>
+                        </a:rPr>
+                        <a:t>72.3%</a:t>
+                      </a:r>
+                    </a:p>
+                  </a:txBody>
+                  <a:tcPr marL="73152" marR="73152" marT="18288" marB="18288" anchor="ctr">
+                    <a:solidFill>
+                      <a:srgbClr val="FFFFFF"/>
+                    </a:solidFill>
+                  </a:tcPr>
+                </a:tc>
+                <a:tc>
+                  <a:txBody>
+                    <a:bodyPr wrap="square"/>
+                    <a:lstStyle/>
+                    <a:p>
+                      <a:pPr algn="r"/>
+                      <a:r>
+                        <a:rPr sz="1100" b="0">
+                          <a:solidFill>
+                            <a:srgbClr val="1F2A30"/>
+                          </a:solidFill>
+                          <a:latin typeface="Arial"/>
+                        </a:rPr>
+                        <a:t>72.3%</a:t>
+                      </a:r>
+                    </a:p>
+                  </a:txBody>
+                  <a:tcPr marL="73152" marR="73152" marT="18288" marB="18288" anchor="ctr">
+                    <a:solidFill>
+                      <a:srgbClr val="FFFFFF"/>
+                    </a:solidFill>
+                  </a:tcPr>
+                </a:tc>
+                <a:tc>
+                  <a:txBody>
+                    <a:bodyPr wrap="square"/>
+                    <a:lstStyle/>
+                    <a:p>
+                      <a:pPr algn="r"/>
+                      <a:r>
+                        <a:rPr sz="1100" b="0">
+                          <a:solidFill>
+                            <a:srgbClr val="1F2A30"/>
+                          </a:solidFill>
+                          <a:latin typeface="Arial"/>
+                        </a:rPr>
+                        <a:t>0</a:t>
+                      </a:r>
+                    </a:p>
+                  </a:txBody>
+                  <a:tcPr marL="73152" marR="73152" marT="18288" marB="18288" anchor="ctr">
+                    <a:solidFill>
+                      <a:srgbClr val="FFFFFF"/>
+                    </a:solidFill>
+                  </a:tcPr>
+                </a:tc>
+                <a:tc>
+                  <a:txBody>
+                    <a:bodyPr wrap="square"/>
+                    <a:lstStyle/>
+                    <a:p>
+                      <a:pPr algn="r"/>
+                      <a:r>
+                        <a:rPr sz="1100" b="0">
+                          <a:solidFill>
+                            <a:srgbClr val="1F2A30"/>
+                          </a:solidFill>
+                          <a:latin typeface="Arial"/>
+                        </a:rPr>
+                        <a:t>1.0000</a:t>
+                      </a:r>
+                    </a:p>
+                  </a:txBody>
+                  <a:tcPr marL="73152" marR="73152" marT="18288" marB="18288" anchor="ctr">
+                    <a:solidFill>
+                      <a:srgbClr val="FFFFFF"/>
+                    </a:solidFill>
+                  </a:tcPr>
+                </a:tc>
+              </a:tr>
+              <a:tr h="283464">
+                <a:tc>
+                  <a:txBody>
+                    <a:bodyPr wrap="square"/>
+                    <a:lstStyle/>
+                    <a:p>
+                      <a:pPr algn="ctr"/>
+                      <a:r>
+                        <a:rPr sz="1100" b="0">
+                          <a:solidFill>
+                            <a:srgbClr val="1F2A30"/>
+                          </a:solidFill>
+                          <a:latin typeface="Arial"/>
+                        </a:rPr>
+                        <a:t>2</a:t>
+                      </a:r>
+                    </a:p>
+                  </a:txBody>
+                  <a:tcPr marL="73152" marR="73152" marT="18288" marB="18288" anchor="ctr">
+                    <a:solidFill>
+                      <a:srgbClr val="F2F8F7"/>
+                    </a:solidFill>
+                  </a:tcPr>
+                </a:tc>
+                <a:tc>
+                  <a:txBody>
+                    <a:bodyPr wrap="square"/>
+                    <a:lstStyle/>
+                    <a:p>
+                      <a:pPr algn="l"/>
+                      <a:r>
+                        <a:rPr sz="1100" b="0">
+                          <a:solidFill>
+                            <a:srgbClr val="1F2A30"/>
+                          </a:solidFill>
+                          <a:latin typeface="Courier New"/>
+                        </a:rPr>
+                        <a:t>GGCGGTGTGTACAAGGCCCGGGAACGTATTCA</a:t>
+                      </a:r>
+                    </a:p>
+                  </a:txBody>
+                  <a:tcPr marL="73152" marR="73152" marT="18288" marB="18288" anchor="ctr">
+                    <a:solidFill>
+                      <a:srgbClr val="F2F8F7"/>
+                    </a:solidFill>
+                  </a:tcPr>
+                </a:tc>
+                <a:tc>
+                  <a:txBody>
+                    <a:bodyPr wrap="square"/>
+                    <a:lstStyle/>
+                    <a:p>
+                      <a:pPr algn="r"/>
+                      <a:r>
+                        <a:rPr sz="1100" b="0">
+                          <a:solidFill>
+                            <a:srgbClr val="1F2A30"/>
+                          </a:solidFill>
+                          <a:latin typeface="Arial"/>
+                        </a:rPr>
+                        <a:t>48.0%</a:t>
+                      </a:r>
+                    </a:p>
+                  </a:txBody>
+                  <a:tcPr marL="73152" marR="73152" marT="18288" marB="18288" anchor="ctr">
+                    <a:solidFill>
+                      <a:srgbClr val="F2F8F7"/>
+                    </a:solidFill>
+                  </a:tcPr>
+                </a:tc>
+                <a:tc>
+                  <a:txBody>
+                    <a:bodyPr wrap="square"/>
+                    <a:lstStyle/>
+                    <a:p>
+                      <a:pPr algn="r"/>
+                      <a:r>
+                        <a:rPr sz="1100" b="0">
+                          <a:solidFill>
+                            <a:srgbClr val="1F2A30"/>
+                          </a:solidFill>
+                          <a:latin typeface="Arial"/>
+                        </a:rPr>
+                        <a:t>84.5%</a:t>
+                      </a:r>
+                    </a:p>
+                  </a:txBody>
+                  <a:tcPr marL="73152" marR="73152" marT="18288" marB="18288" anchor="ctr">
+                    <a:solidFill>
+                      <a:srgbClr val="F2F8F7"/>
+                    </a:solidFill>
+                  </a:tcPr>
+                </a:tc>
+                <a:tc>
+                  <a:txBody>
+                    <a:bodyPr wrap="square"/>
+                    <a:lstStyle/>
+                    <a:p>
+                      <a:pPr algn="r"/>
+                      <a:r>
+                        <a:rPr sz="1100" b="0">
+                          <a:solidFill>
+                            <a:srgbClr val="1F2A30"/>
+                          </a:solidFill>
+                          <a:latin typeface="Arial"/>
+                        </a:rPr>
+                        <a:t>0</a:t>
+                      </a:r>
+                    </a:p>
+                  </a:txBody>
+                  <a:tcPr marL="73152" marR="73152" marT="18288" marB="18288" anchor="ctr">
+                    <a:solidFill>
+                      <a:srgbClr val="F2F8F7"/>
+                    </a:solidFill>
+                  </a:tcPr>
+                </a:tc>
+                <a:tc>
+                  <a:txBody>
+                    <a:bodyPr wrap="square"/>
+                    <a:lstStyle/>
+                    <a:p>
+                      <a:pPr algn="r"/>
+                      <a:r>
+                        <a:rPr sz="1100" b="0">
+                          <a:solidFill>
+                            <a:srgbClr val="1F2A30"/>
+                          </a:solidFill>
+                          <a:latin typeface="Arial"/>
+                        </a:rPr>
+                        <a:t>1.0000</a:t>
+                      </a:r>
+                    </a:p>
+                  </a:txBody>
+                  <a:tcPr marL="73152" marR="73152" marT="18288" marB="18288" anchor="ctr">
+                    <a:solidFill>
+                      <a:srgbClr val="F2F8F7"/>
+                    </a:solidFill>
+                  </a:tcPr>
+                </a:tc>
+              </a:tr>
+              <a:tr h="283464">
+                <a:tc>
+                  <a:txBody>
+                    <a:bodyPr wrap="square"/>
+                    <a:lstStyle/>
+                    <a:p>
+                      <a:pPr algn="ctr"/>
+                      <a:r>
+                        <a:rPr sz="1100" b="0">
+                          <a:solidFill>
+                            <a:srgbClr val="1F2A30"/>
+                          </a:solidFill>
+                          <a:latin typeface="Arial"/>
+                        </a:rPr>
+                        <a:t>3</a:t>
+                      </a:r>
+                    </a:p>
+                  </a:txBody>
+                  <a:tcPr marL="73152" marR="73152" marT="18288" marB="18288" anchor="ctr">
+                    <a:solidFill>
+                      <a:srgbClr val="FFFFFF"/>
+                    </a:solidFill>
+                  </a:tcPr>
+                </a:tc>
+                <a:tc>
+                  <a:txBody>
+                    <a:bodyPr wrap="square"/>
+                    <a:lstStyle/>
+                    <a:p>
+                      <a:pPr algn="l"/>
+                      <a:r>
+                        <a:rPr sz="1100" b="0">
+                          <a:solidFill>
+                            <a:srgbClr val="1F2A30"/>
+                          </a:solidFill>
+                          <a:latin typeface="Courier New"/>
+                        </a:rPr>
+                        <a:t>GCGTGGACTACCAGGGTATCTAATCCTGTTTG</a:t>
+                      </a:r>
+                    </a:p>
+                  </a:txBody>
+                  <a:tcPr marL="73152" marR="73152" marT="18288" marB="18288" anchor="ctr">
+                    <a:solidFill>
+                      <a:srgbClr val="FFFFFF"/>
+                    </a:solidFill>
+                  </a:tcPr>
+                </a:tc>
+                <a:tc>
+                  <a:txBody>
+                    <a:bodyPr wrap="square"/>
+                    <a:lstStyle/>
+                    <a:p>
+                      <a:pPr algn="r"/>
+                      <a:r>
+                        <a:rPr sz="1100" b="0">
+                          <a:solidFill>
+                            <a:srgbClr val="1F2A30"/>
+                          </a:solidFill>
+                          <a:latin typeface="Arial"/>
+                        </a:rPr>
+                        <a:t>51.4%</a:t>
+                      </a:r>
+                    </a:p>
+                  </a:txBody>
+                  <a:tcPr marL="73152" marR="73152" marT="18288" marB="18288" anchor="ctr">
+                    <a:solidFill>
+                      <a:srgbClr val="FFFFFF"/>
+                    </a:solidFill>
+                  </a:tcPr>
+                </a:tc>
+                <a:tc>
+                  <a:txBody>
+                    <a:bodyPr wrap="square"/>
+                    <a:lstStyle/>
+                    <a:p>
+                      <a:pPr algn="r"/>
+                      <a:r>
+                        <a:rPr sz="1100" b="0">
+                          <a:solidFill>
+                            <a:srgbClr val="1F2A30"/>
+                          </a:solidFill>
+                          <a:latin typeface="Arial"/>
+                        </a:rPr>
+                        <a:t>89.1%</a:t>
+                      </a:r>
+                    </a:p>
+                  </a:txBody>
+                  <a:tcPr marL="73152" marR="73152" marT="18288" marB="18288" anchor="ctr">
+                    <a:solidFill>
+                      <a:srgbClr val="FFFFFF"/>
+                    </a:solidFill>
+                  </a:tcPr>
+                </a:tc>
+                <a:tc>
+                  <a:txBody>
+                    <a:bodyPr wrap="square"/>
+                    <a:lstStyle/>
+                    <a:p>
+                      <a:pPr algn="r"/>
+                      <a:r>
+                        <a:rPr sz="1100" b="0">
+                          <a:solidFill>
+                            <a:srgbClr val="1F2A30"/>
+                          </a:solidFill>
+                          <a:latin typeface="Arial"/>
+                        </a:rPr>
+                        <a:t>2</a:t>
+                      </a:r>
+                    </a:p>
+                  </a:txBody>
+                  <a:tcPr marL="73152" marR="73152" marT="18288" marB="18288" anchor="ctr">
+                    <a:solidFill>
+                      <a:srgbClr val="FFFFFF"/>
+                    </a:solidFill>
+                  </a:tcPr>
+                </a:tc>
+                <a:tc>
+                  <a:txBody>
+                    <a:bodyPr wrap="square"/>
+                    <a:lstStyle/>
+                    <a:p>
+                      <a:pPr algn="r"/>
+                      <a:r>
+                        <a:rPr sz="1100" b="0">
+                          <a:solidFill>
+                            <a:srgbClr val="1F2A30"/>
+                          </a:solidFill>
+                          <a:latin typeface="Arial"/>
+                        </a:rPr>
+                        <a:t>0.9999</a:t>
+                      </a:r>
+                    </a:p>
+                  </a:txBody>
+                  <a:tcPr marL="73152" marR="73152" marT="18288" marB="18288" anchor="ctr">
+                    <a:solidFill>
+                      <a:srgbClr val="FFFFFF"/>
+                    </a:solidFill>
+                  </a:tcPr>
+                </a:tc>
+              </a:tr>
+              <a:tr h="283464">
+                <a:tc>
+                  <a:txBody>
+                    <a:bodyPr wrap="square"/>
+                    <a:lstStyle/>
+                    <a:p>
+                      <a:pPr algn="ctr"/>
+                      <a:r>
+                        <a:rPr sz="1100" b="0">
+                          <a:solidFill>
+                            <a:srgbClr val="1F2A30"/>
+                          </a:solidFill>
+                          <a:latin typeface="Arial"/>
+                        </a:rPr>
+                        <a:t>4</a:t>
+                      </a:r>
+                    </a:p>
+                  </a:txBody>
+                  <a:tcPr marL="73152" marR="73152" marT="18288" marB="18288" anchor="ctr">
+                    <a:solidFill>
+                      <a:srgbClr val="F2F8F7"/>
+                    </a:solidFill>
+                  </a:tcPr>
+                </a:tc>
+                <a:tc>
+                  <a:txBody>
+                    <a:bodyPr wrap="square"/>
+                    <a:lstStyle/>
+                    <a:p>
+                      <a:pPr algn="l"/>
+                      <a:r>
+                        <a:rPr sz="1100" b="0">
+                          <a:solidFill>
+                            <a:srgbClr val="1F2A30"/>
+                          </a:solidFill>
+                          <a:latin typeface="Courier New"/>
+                        </a:rPr>
+                        <a:t>GGTAAGGTTCCTCGCGTATCATCGAATTAAAC</a:t>
+                      </a:r>
+                    </a:p>
+                  </a:txBody>
+                  <a:tcPr marL="73152" marR="73152" marT="18288" marB="18288" anchor="ctr">
+                    <a:solidFill>
+                      <a:srgbClr val="F2F8F7"/>
+                    </a:solidFill>
+                  </a:tcPr>
+                </a:tc>
+                <a:tc>
+                  <a:txBody>
+                    <a:bodyPr wrap="square"/>
+                    <a:lstStyle/>
+                    <a:p>
+                      <a:pPr algn="r"/>
+                      <a:r>
+                        <a:rPr sz="1100" b="0">
+                          <a:solidFill>
+                            <a:srgbClr val="1F2A30"/>
+                          </a:solidFill>
+                          <a:latin typeface="Arial"/>
+                        </a:rPr>
+                        <a:t>9.4%</a:t>
+                      </a:r>
+                    </a:p>
+                  </a:txBody>
+                  <a:tcPr marL="73152" marR="73152" marT="18288" marB="18288" anchor="ctr">
+                    <a:solidFill>
+                      <a:srgbClr val="F2F8F7"/>
+                    </a:solidFill>
+                  </a:tcPr>
+                </a:tc>
+                <a:tc>
+                  <a:txBody>
+                    <a:bodyPr wrap="square"/>
+                    <a:lstStyle/>
+                    <a:p>
+                      <a:pPr algn="r"/>
+                      <a:r>
+                        <a:rPr sz="1100" b="0">
+                          <a:solidFill>
+                            <a:srgbClr val="1F2A30"/>
+                          </a:solidFill>
+                          <a:latin typeface="Arial"/>
+                        </a:rPr>
+                        <a:t>91.5%</a:t>
+                      </a:r>
+                    </a:p>
+                  </a:txBody>
+                  <a:tcPr marL="73152" marR="73152" marT="18288" marB="18288" anchor="ctr">
+                    <a:solidFill>
+                      <a:srgbClr val="F2F8F7"/>
+                    </a:solidFill>
+                  </a:tcPr>
+                </a:tc>
+                <a:tc>
+                  <a:txBody>
+                    <a:bodyPr wrap="square"/>
+                    <a:lstStyle/>
+                    <a:p>
+                      <a:pPr algn="r"/>
+                      <a:r>
+                        <a:rPr sz="1100" b="0">
+                          <a:solidFill>
+                            <a:srgbClr val="1F2A30"/>
+                          </a:solidFill>
+                          <a:latin typeface="Arial"/>
+                        </a:rPr>
+                        <a:t>0</a:t>
+                      </a:r>
+                    </a:p>
+                  </a:txBody>
+                  <a:tcPr marL="73152" marR="73152" marT="18288" marB="18288" anchor="ctr">
+                    <a:solidFill>
+                      <a:srgbClr val="F2F8F7"/>
+                    </a:solidFill>
+                  </a:tcPr>
+                </a:tc>
+                <a:tc>
+                  <a:txBody>
+                    <a:bodyPr wrap="square"/>
+                    <a:lstStyle/>
+                    <a:p>
+                      <a:pPr algn="r"/>
+                      <a:r>
+                        <a:rPr sz="1100" b="0">
+                          <a:solidFill>
+                            <a:srgbClr val="1F2A30"/>
+                          </a:solidFill>
+                          <a:latin typeface="Arial"/>
+                        </a:rPr>
+                        <a:t>1.0000</a:t>
+                      </a:r>
+                    </a:p>
+                  </a:txBody>
+                  <a:tcPr marL="73152" marR="73152" marT="18288" marB="18288" anchor="ctr">
+                    <a:solidFill>
+                      <a:srgbClr val="F2F8F7"/>
+                    </a:solidFill>
+                  </a:tcPr>
+                </a:tc>
+              </a:tr>
+              <a:tr h="283464">
+                <a:tc>
+                  <a:txBody>
+                    <a:bodyPr wrap="square"/>
+                    <a:lstStyle/>
+                    <a:p>
+                      <a:pPr algn="ctr"/>
+                      <a:r>
+                        <a:rPr sz="1100" b="0">
+                          <a:solidFill>
+                            <a:srgbClr val="1F2A30"/>
+                          </a:solidFill>
+                          <a:latin typeface="Arial"/>
+                        </a:rPr>
+                        <a:t>5</a:t>
+                      </a:r>
+                    </a:p>
+                  </a:txBody>
+                  <a:tcPr marL="73152" marR="73152" marT="18288" marB="18288" anchor="ctr">
+                    <a:solidFill>
+                      <a:srgbClr val="FFFFFF"/>
+                    </a:solidFill>
+                  </a:tcPr>
+                </a:tc>
+                <a:tc>
+                  <a:txBody>
+                    <a:bodyPr wrap="square"/>
+                    <a:lstStyle/>
+                    <a:p>
+                      <a:pPr algn="l"/>
+                      <a:r>
+                        <a:rPr sz="1100" b="0">
+                          <a:solidFill>
+                            <a:srgbClr val="1F2A30"/>
+                          </a:solidFill>
+                          <a:latin typeface="Courier New"/>
+                        </a:rPr>
+                        <a:t>CTACGTATTACCGCGGCTGCTGGCACGTAGTT</a:t>
+                      </a:r>
+                    </a:p>
+                  </a:txBody>
+                  <a:tcPr marL="73152" marR="73152" marT="18288" marB="18288" anchor="ctr">
+                    <a:solidFill>
+                      <a:srgbClr val="FFFFFF"/>
+                    </a:solidFill>
+                  </a:tcPr>
+                </a:tc>
+                <a:tc>
+                  <a:txBody>
+                    <a:bodyPr wrap="square"/>
+                    <a:lstStyle/>
+                    <a:p>
+                      <a:pPr algn="r"/>
+                      <a:r>
+                        <a:rPr sz="1100" b="0">
+                          <a:solidFill>
+                            <a:srgbClr val="1F2A30"/>
+                          </a:solidFill>
+                          <a:latin typeface="Arial"/>
+                        </a:rPr>
+                        <a:t>36.0%</a:t>
+                      </a:r>
+                    </a:p>
+                  </a:txBody>
+                  <a:tcPr marL="73152" marR="73152" marT="18288" marB="18288" anchor="ctr">
+                    <a:solidFill>
+                      <a:srgbClr val="FFFFFF"/>
+                    </a:solidFill>
+                  </a:tcPr>
+                </a:tc>
+                <a:tc>
+                  <a:txBody>
+                    <a:bodyPr wrap="square"/>
+                    <a:lstStyle/>
+                    <a:p>
+                      <a:pPr algn="r"/>
+                      <a:r>
+                        <a:rPr sz="1100" b="0">
+                          <a:solidFill>
+                            <a:srgbClr val="1F2A30"/>
+                          </a:solidFill>
+                          <a:latin typeface="Arial"/>
+                        </a:rPr>
+                        <a:t>92.9%</a:t>
+                      </a:r>
+                    </a:p>
+                  </a:txBody>
+                  <a:tcPr marL="73152" marR="73152" marT="18288" marB="18288" anchor="ctr">
+                    <a:solidFill>
+                      <a:srgbClr val="FFFFFF"/>
+                    </a:solidFill>
+                  </a:tcPr>
+                </a:tc>
+                <a:tc>
+                  <a:txBody>
+                    <a:bodyPr wrap="square"/>
+                    <a:lstStyle/>
+                    <a:p>
+                      <a:pPr algn="r"/>
+                      <a:r>
+                        <a:rPr sz="1100" b="0">
+                          <a:solidFill>
+                            <a:srgbClr val="1F2A30"/>
+                          </a:solidFill>
+                          <a:latin typeface="Arial"/>
+                        </a:rPr>
+                        <a:t>0</a:t>
+                      </a:r>
+                    </a:p>
+                  </a:txBody>
+                  <a:tcPr marL="73152" marR="73152" marT="18288" marB="18288" anchor="ctr">
+                    <a:solidFill>
+                      <a:srgbClr val="FFFFFF"/>
+                    </a:solidFill>
+                  </a:tcPr>
+                </a:tc>
+                <a:tc>
+                  <a:txBody>
+                    <a:bodyPr wrap="square"/>
+                    <a:lstStyle/>
+                    <a:p>
+                      <a:pPr algn="r"/>
+                      <a:r>
+                        <a:rPr sz="1100" b="0">
+                          <a:solidFill>
+                            <a:srgbClr val="1F2A30"/>
+                          </a:solidFill>
+                          <a:latin typeface="Arial"/>
+                        </a:rPr>
+                        <a:t>1.0000</a:t>
+                      </a:r>
+                    </a:p>
+                  </a:txBody>
+                  <a:tcPr marL="73152" marR="73152" marT="18288" marB="18288" anchor="ctr">
+                    <a:solidFill>
+                      <a:srgbClr val="FFFFFF"/>
+                    </a:solidFill>
+                  </a:tcPr>
+                </a:tc>
+              </a:tr>
+              <a:tr h="283464">
+                <a:tc>
+                  <a:txBody>
+                    <a:bodyPr wrap="square"/>
+                    <a:lstStyle/>
+                    <a:p>
+                      <a:pPr algn="ctr"/>
+                      <a:r>
+                        <a:rPr sz="1100" b="0">
+                          <a:solidFill>
+                            <a:srgbClr val="1F2A30"/>
+                          </a:solidFill>
+                          <a:latin typeface="Arial"/>
+                        </a:rPr>
+                        <a:t>6</a:t>
+                      </a:r>
+                    </a:p>
+                  </a:txBody>
+                  <a:tcPr marL="73152" marR="73152" marT="18288" marB="18288" anchor="ctr">
+                    <a:solidFill>
+                      <a:srgbClr val="F2F8F7"/>
+                    </a:solidFill>
+                  </a:tcPr>
+                </a:tc>
+                <a:tc>
+                  <a:txBody>
+                    <a:bodyPr wrap="square"/>
+                    <a:lstStyle/>
+                    <a:p>
+                      <a:pPr algn="l"/>
+                      <a:r>
+                        <a:rPr sz="1100" b="1">
+                          <a:solidFill>
+                            <a:srgbClr val="1F2A30"/>
+                          </a:solidFill>
+                          <a:latin typeface="Courier New"/>
+                        </a:rPr>
+                        <a:t>ATTCCCCACTGCTGCCTCCCGTAGGAGTCTGG</a:t>
+                      </a:r>
+                    </a:p>
+                  </a:txBody>
+                  <a:tcPr marL="73152" marR="73152" marT="18288" marB="18288" anchor="ctr">
+                    <a:solidFill>
+                      <a:srgbClr val="F2F8F7"/>
+                    </a:solidFill>
+                  </a:tcPr>
+                </a:tc>
+                <a:tc>
+                  <a:txBody>
+                    <a:bodyPr wrap="square"/>
+                    <a:lstStyle/>
+                    <a:p>
+                      <a:pPr algn="r"/>
+                      <a:r>
+                        <a:rPr sz="1100" b="0">
+                          <a:solidFill>
+                            <a:srgbClr val="1F2A30"/>
+                          </a:solidFill>
+                          <a:latin typeface="Arial"/>
+                        </a:rPr>
+                        <a:t>47.2%</a:t>
+                      </a:r>
+                    </a:p>
+                  </a:txBody>
+                  <a:tcPr marL="73152" marR="73152" marT="18288" marB="18288" anchor="ctr">
+                    <a:solidFill>
+                      <a:srgbClr val="F2F8F7"/>
+                    </a:solidFill>
+                  </a:tcPr>
+                </a:tc>
+                <a:tc>
+                  <a:txBody>
+                    <a:bodyPr wrap="square"/>
+                    <a:lstStyle/>
+                    <a:p>
+                      <a:pPr algn="r"/>
+                      <a:r>
+                        <a:rPr sz="1100" b="0">
+                          <a:solidFill>
+                            <a:srgbClr val="1F2A30"/>
+                          </a:solidFill>
+                          <a:latin typeface="Arial"/>
+                        </a:rPr>
+                        <a:t>94.0%</a:t>
+                      </a:r>
+                    </a:p>
+                  </a:txBody>
+                  <a:tcPr marL="73152" marR="73152" marT="18288" marB="18288" anchor="ctr">
+                    <a:solidFill>
+                      <a:srgbClr val="F2F8F7"/>
+                    </a:solidFill>
+                  </a:tcPr>
+                </a:tc>
+                <a:tc>
+                  <a:txBody>
+                    <a:bodyPr wrap="square"/>
+                    <a:lstStyle/>
+                    <a:p>
+                      <a:pPr algn="r"/>
+                      <a:r>
+                        <a:rPr sz="1100" b="0">
+                          <a:solidFill>
+                            <a:srgbClr val="1F2A30"/>
+                          </a:solidFill>
+                          <a:latin typeface="Arial"/>
+                        </a:rPr>
+                        <a:t>2</a:t>
+                      </a:r>
+                    </a:p>
+                  </a:txBody>
+                  <a:tcPr marL="73152" marR="73152" marT="18288" marB="18288" anchor="ctr">
+                    <a:solidFill>
+                      <a:srgbClr val="F2F8F7"/>
+                    </a:solidFill>
+                  </a:tcPr>
+                </a:tc>
+                <a:tc>
+                  <a:txBody>
+                    <a:bodyPr wrap="square"/>
+                    <a:lstStyle/>
+                    <a:p>
+                      <a:pPr algn="r"/>
+                      <a:r>
+                        <a:rPr sz="1100" b="0">
+                          <a:solidFill>
+                            <a:srgbClr val="1F2A30"/>
+                          </a:solidFill>
+                          <a:latin typeface="Arial"/>
+                        </a:rPr>
+                        <a:t>1.0000</a:t>
+                      </a:r>
+                    </a:p>
+                  </a:txBody>
+                  <a:tcPr marL="73152" marR="73152" marT="18288" marB="18288" anchor="ctr">
+                    <a:solidFill>
+                      <a:srgbClr val="F2F8F7"/>
+                    </a:solidFill>
+                  </a:tcPr>
+                </a:tc>
+              </a:tr>
+              <a:tr h="283464">
+                <a:tc>
+                  <a:txBody>
+                    <a:bodyPr wrap="square"/>
+                    <a:lstStyle/>
+                    <a:p>
+                      <a:pPr algn="ctr"/>
+                      <a:r>
+                        <a:rPr sz="1100" b="0">
+                          <a:solidFill>
+                            <a:srgbClr val="1F2A30"/>
+                          </a:solidFill>
+                          <a:latin typeface="Arial"/>
+                        </a:rPr>
+                        <a:t>7</a:t>
+                      </a:r>
+                    </a:p>
+                  </a:txBody>
+                  <a:tcPr marL="73152" marR="73152" marT="18288" marB="18288" anchor="ctr">
+                    <a:solidFill>
+                      <a:srgbClr val="FFFFFF"/>
+                    </a:solidFill>
+                  </a:tcPr>
+                </a:tc>
+                <a:tc>
+                  <a:txBody>
+                    <a:bodyPr wrap="square"/>
+                    <a:lstStyle/>
+                    <a:p>
+                      <a:pPr algn="l"/>
+                      <a:r>
+                        <a:rPr sz="1100" b="0">
+                          <a:solidFill>
+                            <a:srgbClr val="1F2A30"/>
+                          </a:solidFill>
+                          <a:latin typeface="Courier New"/>
+                        </a:rPr>
+                        <a:t>TTGTGCGGGTCCCCGTCAATTCCTTTGAGTTT</a:t>
+                      </a:r>
+                    </a:p>
+                  </a:txBody>
+                  <a:tcPr marL="73152" marR="73152" marT="18288" marB="18288" anchor="ctr">
+                    <a:solidFill>
+                      <a:srgbClr val="FFFFFF"/>
+                    </a:solidFill>
+                  </a:tcPr>
+                </a:tc>
+                <a:tc>
+                  <a:txBody>
+                    <a:bodyPr wrap="square"/>
+                    <a:lstStyle/>
+                    <a:p>
+                      <a:pPr algn="r"/>
+                      <a:r>
+                        <a:rPr sz="1100" b="0">
+                          <a:solidFill>
+                            <a:srgbClr val="1F2A30"/>
+                          </a:solidFill>
+                          <a:latin typeface="Arial"/>
+                        </a:rPr>
+                        <a:t>16.6%</a:t>
+                      </a:r>
+                    </a:p>
+                  </a:txBody>
+                  <a:tcPr marL="73152" marR="73152" marT="18288" marB="18288" anchor="ctr">
+                    <a:solidFill>
+                      <a:srgbClr val="FFFFFF"/>
+                    </a:solidFill>
+                  </a:tcPr>
+                </a:tc>
+                <a:tc>
+                  <a:txBody>
+                    <a:bodyPr wrap="square"/>
+                    <a:lstStyle/>
+                    <a:p>
+                      <a:pPr algn="r"/>
+                      <a:r>
+                        <a:rPr sz="1100" b="0">
+                          <a:solidFill>
+                            <a:srgbClr val="1F2A30"/>
+                          </a:solidFill>
+                          <a:latin typeface="Arial"/>
+                        </a:rPr>
+                        <a:t>94.4%</a:t>
+                      </a:r>
+                    </a:p>
+                  </a:txBody>
+                  <a:tcPr marL="73152" marR="73152" marT="18288" marB="18288" anchor="ctr">
+                    <a:solidFill>
+                      <a:srgbClr val="FFFFFF"/>
+                    </a:solidFill>
+                  </a:tcPr>
+                </a:tc>
+                <a:tc>
+                  <a:txBody>
+                    <a:bodyPr wrap="square"/>
+                    <a:lstStyle/>
+                    <a:p>
+                      <a:pPr algn="r"/>
+                      <a:r>
+                        <a:rPr sz="1100" b="0">
+                          <a:solidFill>
+                            <a:srgbClr val="1F2A30"/>
+                          </a:solidFill>
+                          <a:latin typeface="Arial"/>
+                        </a:rPr>
+                        <a:t>0</a:t>
+                      </a:r>
+                    </a:p>
+                  </a:txBody>
+                  <a:tcPr marL="73152" marR="73152" marT="18288" marB="18288" anchor="ctr">
+                    <a:solidFill>
+                      <a:srgbClr val="FFFFFF"/>
+                    </a:solidFill>
+                  </a:tcPr>
+                </a:tc>
+                <a:tc>
+                  <a:txBody>
+                    <a:bodyPr wrap="square"/>
+                    <a:lstStyle/>
+                    <a:p>
+                      <a:pPr algn="r"/>
+                      <a:r>
+                        <a:rPr sz="1100" b="0">
+                          <a:solidFill>
+                            <a:srgbClr val="1F2A30"/>
+                          </a:solidFill>
+                          <a:latin typeface="Arial"/>
+                        </a:rPr>
+                        <a:t>1.0000</a:t>
+                      </a:r>
+                    </a:p>
+                  </a:txBody>
+                  <a:tcPr marL="73152" marR="73152" marT="18288" marB="18288" anchor="ctr">
+                    <a:solidFill>
+                      <a:srgbClr val="FFFFFF"/>
+                    </a:solidFill>
+                  </a:tcPr>
+                </a:tc>
+              </a:tr>
+              <a:tr h="283464">
+                <a:tc>
+                  <a:txBody>
+                    <a:bodyPr wrap="square"/>
+                    <a:lstStyle/>
+                    <a:p>
+                      <a:pPr algn="ctr"/>
+                      <a:r>
+                        <a:rPr sz="1100" b="0">
+                          <a:solidFill>
+                            <a:srgbClr val="1F2A30"/>
+                          </a:solidFill>
+                          <a:latin typeface="Arial"/>
+                        </a:rPr>
+                        <a:t>8</a:t>
+                      </a:r>
+                    </a:p>
+                  </a:txBody>
+                  <a:tcPr marL="73152" marR="73152" marT="18288" marB="18288" anchor="ctr">
+                    <a:solidFill>
+                      <a:srgbClr val="F2F8F7"/>
+                    </a:solidFill>
+                  </a:tcPr>
+                </a:tc>
+                <a:tc>
+                  <a:txBody>
+                    <a:bodyPr wrap="square"/>
+                    <a:lstStyle/>
+                    <a:p>
+                      <a:pPr algn="l"/>
+                      <a:r>
+                        <a:rPr sz="1100" b="0">
+                          <a:solidFill>
+                            <a:srgbClr val="1F2A30"/>
+                          </a:solidFill>
+                          <a:latin typeface="Courier New"/>
+                        </a:rPr>
+                        <a:t>CTTCATGGAGTCGAGTTGCAGACTCCAATCCG</a:t>
+                      </a:r>
+                    </a:p>
+                  </a:txBody>
+                  <a:tcPr marL="73152" marR="73152" marT="18288" marB="18288" anchor="ctr">
+                    <a:solidFill>
+                      <a:srgbClr val="F2F8F7"/>
+                    </a:solidFill>
+                  </a:tcPr>
+                </a:tc>
+                <a:tc>
+                  <a:txBody>
+                    <a:bodyPr wrap="square"/>
+                    <a:lstStyle/>
+                    <a:p>
+                      <a:pPr algn="r"/>
+                      <a:r>
+                        <a:rPr sz="1100" b="0">
+                          <a:solidFill>
+                            <a:srgbClr val="1F2A30"/>
+                          </a:solidFill>
+                          <a:latin typeface="Arial"/>
+                        </a:rPr>
+                        <a:t>15.6%</a:t>
+                      </a:r>
+                    </a:p>
+                  </a:txBody>
+                  <a:tcPr marL="73152" marR="73152" marT="18288" marB="18288" anchor="ctr">
+                    <a:solidFill>
+                      <a:srgbClr val="F2F8F7"/>
+                    </a:solidFill>
+                  </a:tcPr>
+                </a:tc>
+                <a:tc>
+                  <a:txBody>
+                    <a:bodyPr wrap="square"/>
+                    <a:lstStyle/>
+                    <a:p>
+                      <a:pPr algn="r"/>
+                      <a:r>
+                        <a:rPr sz="1100" b="0">
+                          <a:solidFill>
+                            <a:srgbClr val="1F2A30"/>
+                          </a:solidFill>
+                          <a:latin typeface="Arial"/>
+                        </a:rPr>
+                        <a:t>94.7%</a:t>
+                      </a:r>
+                    </a:p>
+                  </a:txBody>
+                  <a:tcPr marL="73152" marR="73152" marT="18288" marB="18288" anchor="ctr">
+                    <a:solidFill>
+                      <a:srgbClr val="F2F8F7"/>
+                    </a:solidFill>
+                  </a:tcPr>
+                </a:tc>
+                <a:tc>
+                  <a:txBody>
+                    <a:bodyPr wrap="square"/>
+                    <a:lstStyle/>
+                    <a:p>
+                      <a:pPr algn="r"/>
+                      <a:r>
+                        <a:rPr sz="1100" b="0">
+                          <a:solidFill>
+                            <a:srgbClr val="1F2A30"/>
+                          </a:solidFill>
+                          <a:latin typeface="Arial"/>
+                        </a:rPr>
+                        <a:t>0</a:t>
+                      </a:r>
+                    </a:p>
+                  </a:txBody>
+                  <a:tcPr marL="73152" marR="73152" marT="18288" marB="18288" anchor="ctr">
+                    <a:solidFill>
+                      <a:srgbClr val="F2F8F7"/>
+                    </a:solidFill>
+                  </a:tcPr>
+                </a:tc>
+                <a:tc>
+                  <a:txBody>
+                    <a:bodyPr wrap="square"/>
+                    <a:lstStyle/>
+                    <a:p>
+                      <a:pPr algn="r"/>
+                      <a:r>
+                        <a:rPr sz="1100" b="0">
+                          <a:solidFill>
+                            <a:srgbClr val="1F2A30"/>
+                          </a:solidFill>
+                          <a:latin typeface="Arial"/>
+                        </a:rPr>
+                        <a:t>1.0000</a:t>
+                      </a:r>
+                    </a:p>
+                  </a:txBody>
+                  <a:tcPr marL="73152" marR="73152" marT="18288" marB="18288" anchor="ctr">
+                    <a:solidFill>
+                      <a:srgbClr val="F2F8F7"/>
+                    </a:solidFill>
+                  </a:tcPr>
+                </a:tc>
+              </a:tr>
+              <a:tr h="283464">
+                <a:tc>
+                  <a:txBody>
+                    <a:bodyPr wrap="square"/>
+                    <a:lstStyle/>
+                    <a:p>
+                      <a:pPr algn="ctr"/>
+                      <a:r>
+                        <a:rPr sz="1100" b="0">
+                          <a:solidFill>
+                            <a:srgbClr val="1F2A30"/>
+                          </a:solidFill>
+                          <a:latin typeface="Arial"/>
+                        </a:rPr>
+                        <a:t>9</a:t>
+                      </a:r>
+                    </a:p>
+                  </a:txBody>
+                  <a:tcPr marL="73152" marR="73152" marT="18288" marB="18288" anchor="ctr">
+                    <a:solidFill>
+                      <a:srgbClr val="FFFFFF"/>
+                    </a:solidFill>
+                  </a:tcPr>
+                </a:tc>
+                <a:tc>
+                  <a:txBody>
+                    <a:bodyPr wrap="square"/>
+                    <a:lstStyle/>
+                    <a:p>
+                      <a:pPr algn="l"/>
+                      <a:r>
+                        <a:rPr sz="1100" b="0">
+                          <a:solidFill>
+                            <a:srgbClr val="1F2A30"/>
+                          </a:solidFill>
+                          <a:latin typeface="Courier New"/>
+                        </a:rPr>
+                        <a:t>CATGATGACTTGACGTCATCCCCACCTTCCTC</a:t>
+                      </a:r>
+                    </a:p>
+                  </a:txBody>
+                  <a:tcPr marL="73152" marR="73152" marT="18288" marB="18288" anchor="ctr">
+                    <a:solidFill>
+                      <a:srgbClr val="FFFFFF"/>
+                    </a:solidFill>
+                  </a:tcPr>
+                </a:tc>
+                <a:tc>
+                  <a:txBody>
+                    <a:bodyPr wrap="square"/>
+                    <a:lstStyle/>
+                    <a:p>
+                      <a:pPr algn="r"/>
+                      <a:r>
+                        <a:rPr sz="1100" b="0">
+                          <a:solidFill>
+                            <a:srgbClr val="1F2A30"/>
+                          </a:solidFill>
+                          <a:latin typeface="Arial"/>
+                        </a:rPr>
+                        <a:t>16.7%</a:t>
+                      </a:r>
+                    </a:p>
+                  </a:txBody>
+                  <a:tcPr marL="73152" marR="73152" marT="18288" marB="18288" anchor="ctr">
+                    <a:solidFill>
+                      <a:srgbClr val="FFFFFF"/>
+                    </a:solidFill>
+                  </a:tcPr>
+                </a:tc>
+                <a:tc>
+                  <a:txBody>
+                    <a:bodyPr wrap="square"/>
+                    <a:lstStyle/>
+                    <a:p>
+                      <a:pPr algn="r"/>
+                      <a:r>
+                        <a:rPr sz="1100" b="0">
+                          <a:solidFill>
+                            <a:srgbClr val="1F2A30"/>
+                          </a:solidFill>
+                          <a:latin typeface="Arial"/>
+                        </a:rPr>
+                        <a:t>94.9%</a:t>
+                      </a:r>
+                    </a:p>
+                  </a:txBody>
+                  <a:tcPr marL="73152" marR="73152" marT="18288" marB="18288" anchor="ctr">
+                    <a:solidFill>
+                      <a:srgbClr val="FFFFFF"/>
+                    </a:solidFill>
+                  </a:tcPr>
+                </a:tc>
+                <a:tc>
+                  <a:txBody>
+                    <a:bodyPr wrap="square"/>
+                    <a:lstStyle/>
+                    <a:p>
+                      <a:pPr algn="r"/>
+                      <a:r>
+                        <a:rPr sz="1100" b="0">
+                          <a:solidFill>
+                            <a:srgbClr val="1F2A30"/>
+                          </a:solidFill>
+                          <a:latin typeface="Arial"/>
+                        </a:rPr>
+                        <a:t>0</a:t>
+                      </a:r>
+                    </a:p>
+                  </a:txBody>
+                  <a:tcPr marL="73152" marR="73152" marT="18288" marB="18288" anchor="ctr">
+                    <a:solidFill>
+                      <a:srgbClr val="FFFFFF"/>
+                    </a:solidFill>
+                  </a:tcPr>
+                </a:tc>
+                <a:tc>
+                  <a:txBody>
+                    <a:bodyPr wrap="square"/>
+                    <a:lstStyle/>
+                    <a:p>
+                      <a:pPr algn="r"/>
+                      <a:r>
+                        <a:rPr sz="1100" b="0">
+                          <a:solidFill>
+                            <a:srgbClr val="1F2A30"/>
+                          </a:solidFill>
+                          <a:latin typeface="Arial"/>
+                        </a:rPr>
+                        <a:t>1.0000</a:t>
+                      </a:r>
+                    </a:p>
+                  </a:txBody>
+                  <a:tcPr marL="73152" marR="73152" marT="18288" marB="18288" anchor="ctr">
+                    <a:solidFill>
+                      <a:srgbClr val="FFFFFF"/>
+                    </a:solidFill>
+                  </a:tcPr>
+                </a:tc>
+              </a:tr>
+              <a:tr h="283464">
+                <a:tc>
+                  <a:txBody>
+                    <a:bodyPr wrap="square"/>
+                    <a:lstStyle/>
+                    <a:p>
+                      <a:pPr algn="ctr"/>
+                      <a:r>
+                        <a:rPr sz="1100" b="0">
+                          <a:solidFill>
+                            <a:srgbClr val="1F2A30"/>
+                          </a:solidFill>
+                          <a:latin typeface="Arial"/>
+                        </a:rPr>
+                        <a:t>10</a:t>
+                      </a:r>
+                    </a:p>
+                  </a:txBody>
+                  <a:tcPr marL="73152" marR="73152" marT="18288" marB="18288" anchor="ctr">
+                    <a:solidFill>
+                      <a:srgbClr val="F2F8F7"/>
+                    </a:solidFill>
+                  </a:tcPr>
+                </a:tc>
+                <a:tc>
+                  <a:txBody>
+                    <a:bodyPr wrap="square"/>
+                    <a:lstStyle/>
+                    <a:p>
+                      <a:pPr algn="l"/>
+                      <a:r>
+                        <a:rPr sz="1100" b="0">
+                          <a:solidFill>
+                            <a:srgbClr val="1F2A30"/>
+                          </a:solidFill>
+                          <a:latin typeface="Courier New"/>
+                        </a:rPr>
+                        <a:t>GGTAAGGTTCTTCGCGTTGCTTCGAATTAAAC</a:t>
+                      </a:r>
+                    </a:p>
+                  </a:txBody>
+                  <a:tcPr marL="73152" marR="73152" marT="18288" marB="18288" anchor="ctr">
+                    <a:solidFill>
+                      <a:srgbClr val="F2F8F7"/>
+                    </a:solidFill>
+                  </a:tcPr>
+                </a:tc>
+                <a:tc>
+                  <a:txBody>
+                    <a:bodyPr wrap="square"/>
+                    <a:lstStyle/>
+                    <a:p>
+                      <a:pPr algn="r"/>
+                      <a:r>
+                        <a:rPr sz="1100" b="0">
+                          <a:solidFill>
+                            <a:srgbClr val="1F2A30"/>
+                          </a:solidFill>
+                          <a:latin typeface="Arial"/>
+                        </a:rPr>
+                        <a:t>22.8%</a:t>
+                      </a:r>
+                    </a:p>
+                  </a:txBody>
+                  <a:tcPr marL="73152" marR="73152" marT="18288" marB="18288" anchor="ctr">
+                    <a:solidFill>
+                      <a:srgbClr val="F2F8F7"/>
+                    </a:solidFill>
+                  </a:tcPr>
+                </a:tc>
+                <a:tc>
+                  <a:txBody>
+                    <a:bodyPr wrap="square"/>
+                    <a:lstStyle/>
+                    <a:p>
+                      <a:pPr algn="r"/>
+                      <a:r>
+                        <a:rPr sz="1100" b="0">
+                          <a:solidFill>
+                            <a:srgbClr val="1F2A30"/>
+                          </a:solidFill>
+                          <a:latin typeface="Arial"/>
+                        </a:rPr>
+                        <a:t>95.1%</a:t>
+                      </a:r>
+                    </a:p>
+                  </a:txBody>
+                  <a:tcPr marL="73152" marR="73152" marT="18288" marB="18288" anchor="ctr">
+                    <a:solidFill>
+                      <a:srgbClr val="F2F8F7"/>
+                    </a:solidFill>
+                  </a:tcPr>
+                </a:tc>
+                <a:tc>
+                  <a:txBody>
+                    <a:bodyPr wrap="square"/>
+                    <a:lstStyle/>
+                    <a:p>
+                      <a:pPr algn="r"/>
+                      <a:r>
+                        <a:rPr sz="1100" b="0">
+                          <a:solidFill>
+                            <a:srgbClr val="1F2A30"/>
+                          </a:solidFill>
+                          <a:latin typeface="Arial"/>
+                        </a:rPr>
+                        <a:t>0</a:t>
+                      </a:r>
+                    </a:p>
+                  </a:txBody>
+                  <a:tcPr marL="73152" marR="73152" marT="18288" marB="18288" anchor="ctr">
+                    <a:solidFill>
+                      <a:srgbClr val="F2F8F7"/>
+                    </a:solidFill>
+                  </a:tcPr>
+                </a:tc>
+                <a:tc>
+                  <a:txBody>
+                    <a:bodyPr wrap="square"/>
+                    <a:lstStyle/>
+                    <a:p>
+                      <a:pPr algn="r"/>
+                      <a:r>
+                        <a:rPr sz="1100" b="0">
+                          <a:solidFill>
+                            <a:srgbClr val="1F2A30"/>
+                          </a:solidFill>
+                          <a:latin typeface="Arial"/>
+                        </a:rPr>
+                        <a:t>1.0000</a:t>
+                      </a:r>
+                    </a:p>
+                  </a:txBody>
+                  <a:tcPr marL="73152" marR="73152" marT="18288" marB="18288" anchor="ctr">
+                    <a:solidFill>
+                      <a:srgbClr val="F2F8F7"/>
+                    </a:solidFill>
+                  </a:tcPr>
+                </a:tc>
+              </a:tr>
+              <a:tr h="283464">
+                <a:tc>
+                  <a:txBody>
+                    <a:bodyPr wrap="square"/>
+                    <a:lstStyle/>
+                    <a:p>
+                      <a:pPr algn="ctr"/>
+                      <a:r>
+                        <a:rPr sz="1100" b="0">
+                          <a:solidFill>
+                            <a:srgbClr val="1F2A30"/>
+                          </a:solidFill>
+                          <a:latin typeface="Arial"/>
+                        </a:rPr>
+                        <a:t>11</a:t>
+                      </a:r>
+                    </a:p>
+                  </a:txBody>
+                  <a:tcPr marL="73152" marR="73152" marT="18288" marB="18288" anchor="ctr">
+                    <a:solidFill>
+                      <a:srgbClr val="FFFFFF"/>
+                    </a:solidFill>
+                  </a:tcPr>
+                </a:tc>
+                <a:tc>
+                  <a:txBody>
+                    <a:bodyPr wrap="square"/>
+                    <a:lstStyle/>
+                    <a:p>
+                      <a:pPr algn="l"/>
+                      <a:r>
+                        <a:rPr sz="1100" b="0">
+                          <a:solidFill>
+                            <a:srgbClr val="1F2A30"/>
+                          </a:solidFill>
+                          <a:latin typeface="Courier New"/>
+                        </a:rPr>
+                        <a:t>CAGTGTGGCTGATCATCCTCTCAGACCAGCTA</a:t>
+                      </a:r>
+                    </a:p>
+                  </a:txBody>
+                  <a:tcPr marL="73152" marR="73152" marT="18288" marB="18288" anchor="ctr">
+                    <a:solidFill>
+                      <a:srgbClr val="FFFFFF"/>
+                    </a:solidFill>
+                  </a:tcPr>
+                </a:tc>
+                <a:tc>
+                  <a:txBody>
+                    <a:bodyPr wrap="square"/>
+                    <a:lstStyle/>
+                    <a:p>
+                      <a:pPr algn="r"/>
+                      <a:r>
+                        <a:rPr sz="1100" b="0">
+                          <a:solidFill>
+                            <a:srgbClr val="1F2A30"/>
+                          </a:solidFill>
+                          <a:latin typeface="Arial"/>
+                        </a:rPr>
+                        <a:t>10.6%</a:t>
+                      </a:r>
+                    </a:p>
+                  </a:txBody>
+                  <a:tcPr marL="73152" marR="73152" marT="18288" marB="18288" anchor="ctr">
+                    <a:solidFill>
+                      <a:srgbClr val="FFFFFF"/>
+                    </a:solidFill>
+                  </a:tcPr>
+                </a:tc>
+                <a:tc>
+                  <a:txBody>
+                    <a:bodyPr wrap="square"/>
+                    <a:lstStyle/>
+                    <a:p>
+                      <a:pPr algn="r"/>
+                      <a:r>
+                        <a:rPr sz="1100" b="0">
+                          <a:solidFill>
+                            <a:srgbClr val="1F2A30"/>
+                          </a:solidFill>
+                          <a:latin typeface="Arial"/>
+                        </a:rPr>
+                        <a:t>95.2%</a:t>
+                      </a:r>
+                    </a:p>
+                  </a:txBody>
+                  <a:tcPr marL="73152" marR="73152" marT="18288" marB="18288" anchor="ctr">
+                    <a:solidFill>
+                      <a:srgbClr val="FFFFFF"/>
+                    </a:solidFill>
+                  </a:tcPr>
+                </a:tc>
+                <a:tc>
+                  <a:txBody>
+                    <a:bodyPr wrap="square"/>
+                    <a:lstStyle/>
+                    <a:p>
+                      <a:pPr algn="r"/>
+                      <a:r>
+                        <a:rPr sz="1100" b="0">
+                          <a:solidFill>
+                            <a:srgbClr val="1F2A30"/>
+                          </a:solidFill>
+                          <a:latin typeface="Arial"/>
+                        </a:rPr>
+                        <a:t>0</a:t>
+                      </a:r>
+                    </a:p>
+                  </a:txBody>
+                  <a:tcPr marL="73152" marR="73152" marT="18288" marB="18288" anchor="ctr">
+                    <a:solidFill>
+                      <a:srgbClr val="FFFFFF"/>
+                    </a:solidFill>
+                  </a:tcPr>
+                </a:tc>
+                <a:tc>
+                  <a:txBody>
+                    <a:bodyPr wrap="square"/>
+                    <a:lstStyle/>
+                    <a:p>
+                      <a:pPr algn="r"/>
+                      <a:r>
+                        <a:rPr sz="1100" b="0">
+                          <a:solidFill>
+                            <a:srgbClr val="1F2A30"/>
+                          </a:solidFill>
+                          <a:latin typeface="Arial"/>
+                        </a:rPr>
+                        <a:t>1.0000</a:t>
+                      </a:r>
+                    </a:p>
+                  </a:txBody>
+                  <a:tcPr marL="73152" marR="73152" marT="18288" marB="18288" anchor="ctr">
+                    <a:solidFill>
+                      <a:srgbClr val="FFFFFF"/>
+                    </a:solidFill>
+                  </a:tcPr>
+                </a:tc>
+              </a:tr>
+              <a:tr h="283464">
+                <a:tc>
+                  <a:txBody>
+                    <a:bodyPr wrap="square"/>
+                    <a:lstStyle/>
+                    <a:p>
+                      <a:pPr algn="ctr"/>
+                      <a:r>
+                        <a:rPr sz="1100" b="0">
+                          <a:solidFill>
+                            <a:srgbClr val="1F2A30"/>
+                          </a:solidFill>
+                          <a:latin typeface="Arial"/>
+                        </a:rPr>
+                        <a:t>12</a:t>
+                      </a:r>
+                    </a:p>
+                  </a:txBody>
+                  <a:tcPr marL="73152" marR="73152" marT="18288" marB="18288" anchor="ctr">
+                    <a:solidFill>
+                      <a:srgbClr val="F2F8F7"/>
+                    </a:solidFill>
+                  </a:tcPr>
+                </a:tc>
+                <a:tc>
+                  <a:txBody>
+                    <a:bodyPr wrap="square"/>
+                    <a:lstStyle/>
+                    <a:p>
+                      <a:pPr algn="l"/>
+                      <a:r>
+                        <a:rPr sz="1100" b="0">
+                          <a:solidFill>
+                            <a:srgbClr val="1F2A30"/>
+                          </a:solidFill>
+                          <a:latin typeface="Courier New"/>
+                        </a:rPr>
+                        <a:t>ACTTGCATGTGTTAAGCACGCCGCCAGCGTTC</a:t>
+                      </a:r>
+                    </a:p>
+                  </a:txBody>
+                  <a:tcPr marL="73152" marR="73152" marT="18288" marB="18288" anchor="ctr">
+                    <a:solidFill>
+                      <a:srgbClr val="F2F8F7"/>
+                    </a:solidFill>
+                  </a:tcPr>
+                </a:tc>
+                <a:tc>
+                  <a:txBody>
+                    <a:bodyPr wrap="square"/>
+                    <a:lstStyle/>
+                    <a:p>
+                      <a:pPr algn="r"/>
+                      <a:r>
+                        <a:rPr sz="1100" b="0">
+                          <a:solidFill>
+                            <a:srgbClr val="1F2A30"/>
+                          </a:solidFill>
+                          <a:latin typeface="Arial"/>
+                        </a:rPr>
+                        <a:t>11.0%</a:t>
+                      </a:r>
+                    </a:p>
+                  </a:txBody>
+                  <a:tcPr marL="73152" marR="73152" marT="18288" marB="18288" anchor="ctr">
+                    <a:solidFill>
+                      <a:srgbClr val="F2F8F7"/>
+                    </a:solidFill>
+                  </a:tcPr>
+                </a:tc>
+                <a:tc>
+                  <a:txBody>
+                    <a:bodyPr wrap="square"/>
+                    <a:lstStyle/>
+                    <a:p>
+                      <a:pPr algn="r"/>
+                      <a:r>
+                        <a:rPr sz="1100" b="0">
+                          <a:solidFill>
+                            <a:srgbClr val="1F2A30"/>
+                          </a:solidFill>
+                          <a:latin typeface="Arial"/>
+                        </a:rPr>
+                        <a:t>95.2%</a:t>
+                      </a:r>
+                    </a:p>
+                  </a:txBody>
+                  <a:tcPr marL="73152" marR="73152" marT="18288" marB="18288" anchor="ctr">
+                    <a:solidFill>
+                      <a:srgbClr val="F2F8F7"/>
+                    </a:solidFill>
+                  </a:tcPr>
+                </a:tc>
+                <a:tc>
+                  <a:txBody>
+                    <a:bodyPr wrap="square"/>
+                    <a:lstStyle/>
+                    <a:p>
+                      <a:pPr algn="r"/>
+                      <a:r>
+                        <a:rPr sz="1100" b="0">
+                          <a:solidFill>
+                            <a:srgbClr val="1F2A30"/>
+                          </a:solidFill>
+                          <a:latin typeface="Arial"/>
+                        </a:rPr>
+                        <a:t>0</a:t>
+                      </a:r>
+                    </a:p>
+                  </a:txBody>
+                  <a:tcPr marL="73152" marR="73152" marT="18288" marB="18288" anchor="ctr">
+                    <a:solidFill>
+                      <a:srgbClr val="F2F8F7"/>
+                    </a:solidFill>
+                  </a:tcPr>
+                </a:tc>
+                <a:tc>
+                  <a:txBody>
+                    <a:bodyPr wrap="square"/>
+                    <a:lstStyle/>
+                    <a:p>
+                      <a:pPr algn="r"/>
+                      <a:r>
+                        <a:rPr sz="1100" b="0">
+                          <a:solidFill>
+                            <a:srgbClr val="1F2A30"/>
+                          </a:solidFill>
+                          <a:latin typeface="Arial"/>
+                        </a:rPr>
+                        <a:t>1.0000</a:t>
+                      </a:r>
+                    </a:p>
+                  </a:txBody>
+                  <a:tcPr marL="73152" marR="73152" marT="18288" marB="18288" anchor="ctr">
+                    <a:solidFill>
+                      <a:srgbClr val="F2F8F7"/>
+                    </a:solidFill>
+                  </a:tcPr>
+                </a:tc>
+              </a:tr>
+              <a:tr h="283464">
+                <a:tc>
+                  <a:txBody>
+                    <a:bodyPr wrap="square"/>
+                    <a:lstStyle/>
+                    <a:p>
+                      <a:pPr algn="ctr"/>
+                      <a:r>
+                        <a:rPr sz="1100" b="0">
+                          <a:solidFill>
+                            <a:srgbClr val="1F2A30"/>
+                          </a:solidFill>
+                          <a:latin typeface="Arial"/>
+                        </a:rPr>
+                        <a:t>13</a:t>
+                      </a:r>
+                    </a:p>
+                  </a:txBody>
+                  <a:tcPr marL="73152" marR="73152" marT="18288" marB="18288" anchor="ctr">
+                    <a:solidFill>
+                      <a:srgbClr val="FFFFFF"/>
+                    </a:solidFill>
+                  </a:tcPr>
+                </a:tc>
+                <a:tc>
+                  <a:txBody>
+                    <a:bodyPr wrap="square"/>
+                    <a:lstStyle/>
+                    <a:p>
+                      <a:pPr algn="l"/>
+                      <a:r>
+                        <a:rPr sz="1100" b="0">
+                          <a:solidFill>
+                            <a:srgbClr val="1F2A30"/>
+                          </a:solidFill>
+                          <a:latin typeface="Courier New"/>
+                        </a:rPr>
+                        <a:t>CATAAGGGGCATGATGATTTGACGTCATCCCC</a:t>
+                      </a:r>
+                    </a:p>
+                  </a:txBody>
+                  <a:tcPr marL="73152" marR="73152" marT="18288" marB="18288" anchor="ctr">
+                    <a:solidFill>
+                      <a:srgbClr val="FFFFFF"/>
+                    </a:solidFill>
+                  </a:tcPr>
+                </a:tc>
+                <a:tc>
+                  <a:txBody>
+                    <a:bodyPr wrap="square"/>
+                    <a:lstStyle/>
+                    <a:p>
+                      <a:pPr algn="r"/>
+                      <a:r>
+                        <a:rPr sz="1100" b="0">
+                          <a:solidFill>
+                            <a:srgbClr val="1F2A30"/>
+                          </a:solidFill>
+                          <a:latin typeface="Arial"/>
+                        </a:rPr>
+                        <a:t>19.9%</a:t>
+                      </a:r>
+                    </a:p>
+                  </a:txBody>
+                  <a:tcPr marL="73152" marR="73152" marT="18288" marB="18288" anchor="ctr">
+                    <a:solidFill>
+                      <a:srgbClr val="FFFFFF"/>
+                    </a:solidFill>
+                  </a:tcPr>
+                </a:tc>
+                <a:tc>
+                  <a:txBody>
+                    <a:bodyPr wrap="square"/>
+                    <a:lstStyle/>
+                    <a:p>
+                      <a:pPr algn="r"/>
+                      <a:r>
+                        <a:rPr sz="1100" b="0">
+                          <a:solidFill>
+                            <a:srgbClr val="1F2A30"/>
+                          </a:solidFill>
+                          <a:latin typeface="Arial"/>
+                        </a:rPr>
+                        <a:t>95.2%</a:t>
+                      </a:r>
+                    </a:p>
+                  </a:txBody>
+                  <a:tcPr marL="73152" marR="73152" marT="18288" marB="18288" anchor="ctr">
+                    <a:solidFill>
+                      <a:srgbClr val="FFFFFF"/>
+                    </a:solidFill>
+                  </a:tcPr>
+                </a:tc>
+                <a:tc>
+                  <a:txBody>
+                    <a:bodyPr wrap="square"/>
+                    <a:lstStyle/>
+                    <a:p>
+                      <a:pPr algn="r"/>
+                      <a:r>
+                        <a:rPr sz="1100" b="0">
+                          <a:solidFill>
+                            <a:srgbClr val="1F2A30"/>
+                          </a:solidFill>
+                          <a:latin typeface="Arial"/>
+                        </a:rPr>
+                        <a:t>0</a:t>
+                      </a:r>
+                    </a:p>
+                  </a:txBody>
+                  <a:tcPr marL="73152" marR="73152" marT="18288" marB="18288" anchor="ctr">
+                    <a:solidFill>
+                      <a:srgbClr val="FFFFFF"/>
+                    </a:solidFill>
+                  </a:tcPr>
+                </a:tc>
+                <a:tc>
+                  <a:txBody>
+                    <a:bodyPr wrap="square"/>
+                    <a:lstStyle/>
+                    <a:p>
+                      <a:pPr algn="r"/>
+                      <a:r>
+                        <a:rPr sz="1100" b="0">
+                          <a:solidFill>
+                            <a:srgbClr val="1F2A30"/>
+                          </a:solidFill>
+                          <a:latin typeface="Arial"/>
+                        </a:rPr>
+                        <a:t>1.0000</a:t>
+                      </a:r>
+                    </a:p>
+                  </a:txBody>
+                  <a:tcPr marL="73152" marR="73152" marT="18288" marB="18288" anchor="ctr">
+                    <a:solidFill>
+                      <a:srgbClr val="FFFFFF"/>
+                    </a:solidFill>
+                  </a:tcPr>
+                </a:tc>
+              </a:tr>
+              <a:tr h="283464">
+                <a:tc>
+                  <a:txBody>
+                    <a:bodyPr wrap="square"/>
+                    <a:lstStyle/>
+                    <a:p>
+                      <a:pPr algn="ctr"/>
+                      <a:r>
+                        <a:rPr sz="1100" b="0">
+                          <a:solidFill>
+                            <a:srgbClr val="1F2A30"/>
+                          </a:solidFill>
+                          <a:latin typeface="Arial"/>
+                        </a:rPr>
+                        <a:t>14</a:t>
+                      </a:r>
+                    </a:p>
+                  </a:txBody>
+                  <a:tcPr marL="73152" marR="73152" marT="18288" marB="18288" anchor="ctr">
+                    <a:solidFill>
+                      <a:srgbClr val="F2F8F7"/>
+                    </a:solidFill>
+                  </a:tcPr>
+                </a:tc>
+                <a:tc>
+                  <a:txBody>
+                    <a:bodyPr wrap="square"/>
+                    <a:lstStyle/>
+                    <a:p>
+                      <a:pPr algn="l"/>
+                      <a:r>
+                        <a:rPr sz="1100" b="0">
+                          <a:solidFill>
+                            <a:srgbClr val="1F2A30"/>
+                          </a:solidFill>
+                          <a:latin typeface="Courier New"/>
+                        </a:rPr>
+                        <a:t>GGCTGCTGGCACGGAGTTAGCCGGTGCTTCTT</a:t>
+                      </a:r>
+                    </a:p>
+                  </a:txBody>
+                  <a:tcPr marL="73152" marR="73152" marT="18288" marB="18288" anchor="ctr">
+                    <a:solidFill>
+                      <a:srgbClr val="F2F8F7"/>
+                    </a:solidFill>
+                  </a:tcPr>
+                </a:tc>
+                <a:tc>
+                  <a:txBody>
+                    <a:bodyPr wrap="square"/>
+                    <a:lstStyle/>
+                    <a:p>
+                      <a:pPr algn="r"/>
+                      <a:r>
+                        <a:rPr sz="1100" b="0">
+                          <a:solidFill>
+                            <a:srgbClr val="1F2A30"/>
+                          </a:solidFill>
+                          <a:latin typeface="Arial"/>
+                        </a:rPr>
+                        <a:t>10.9%</a:t>
+                      </a:r>
+                    </a:p>
+                  </a:txBody>
+                  <a:tcPr marL="73152" marR="73152" marT="18288" marB="18288" anchor="ctr">
+                    <a:solidFill>
+                      <a:srgbClr val="F2F8F7"/>
+                    </a:solidFill>
+                  </a:tcPr>
+                </a:tc>
+                <a:tc>
+                  <a:txBody>
+                    <a:bodyPr wrap="square"/>
+                    <a:lstStyle/>
+                    <a:p>
+                      <a:pPr algn="r"/>
+                      <a:r>
+                        <a:rPr sz="1100" b="0">
+                          <a:solidFill>
+                            <a:srgbClr val="1F2A30"/>
+                          </a:solidFill>
+                          <a:latin typeface="Arial"/>
+                        </a:rPr>
+                        <a:t>95.3%</a:t>
+                      </a:r>
+                    </a:p>
+                  </a:txBody>
+                  <a:tcPr marL="73152" marR="73152" marT="18288" marB="18288" anchor="ctr">
+                    <a:solidFill>
+                      <a:srgbClr val="F2F8F7"/>
+                    </a:solidFill>
+                  </a:tcPr>
+                </a:tc>
+                <a:tc>
+                  <a:txBody>
+                    <a:bodyPr wrap="square"/>
+                    <a:lstStyle/>
+                    <a:p>
+                      <a:pPr algn="r"/>
+                      <a:r>
+                        <a:rPr sz="1100" b="0">
+                          <a:solidFill>
+                            <a:srgbClr val="1F2A30"/>
+                          </a:solidFill>
+                          <a:latin typeface="Arial"/>
+                        </a:rPr>
+                        <a:t>0</a:t>
+                      </a:r>
+                    </a:p>
+                  </a:txBody>
+                  <a:tcPr marL="73152" marR="73152" marT="18288" marB="18288" anchor="ctr">
+                    <a:solidFill>
+                      <a:srgbClr val="F2F8F7"/>
+                    </a:solidFill>
+                  </a:tcPr>
+                </a:tc>
+                <a:tc>
+                  <a:txBody>
+                    <a:bodyPr wrap="square"/>
+                    <a:lstStyle/>
+                    <a:p>
+                      <a:pPr algn="r"/>
+                      <a:r>
+                        <a:rPr sz="1100" b="0">
+                          <a:solidFill>
+                            <a:srgbClr val="1F2A30"/>
+                          </a:solidFill>
+                          <a:latin typeface="Arial"/>
+                        </a:rPr>
+                        <a:t>1.0000</a:t>
+                      </a:r>
+                    </a:p>
+                  </a:txBody>
+                  <a:tcPr marL="73152" marR="73152" marT="18288" marB="18288" anchor="ctr">
+                    <a:solidFill>
+                      <a:srgbClr val="F2F8F7"/>
+                    </a:solidFill>
+                  </a:tcPr>
+                </a:tc>
+              </a:tr>
+              <a:tr h="283464">
+                <a:tc>
+                  <a:txBody>
+                    <a:bodyPr wrap="square"/>
+                    <a:lstStyle/>
+                    <a:p>
+                      <a:pPr algn="ctr"/>
+                      <a:r>
+                        <a:rPr sz="1100" b="0">
+                          <a:solidFill>
+                            <a:srgbClr val="1F2A30"/>
+                          </a:solidFill>
+                          <a:latin typeface="Arial"/>
+                        </a:rPr>
+                        <a:t>15</a:t>
+                      </a:r>
+                    </a:p>
+                  </a:txBody>
+                  <a:tcPr marL="73152" marR="73152" marT="18288" marB="18288" anchor="ctr">
+                    <a:solidFill>
+                      <a:srgbClr val="FFFFFF"/>
+                    </a:solidFill>
+                  </a:tcPr>
+                </a:tc>
+                <a:tc>
+                  <a:txBody>
+                    <a:bodyPr wrap="square"/>
+                    <a:lstStyle/>
+                    <a:p>
+                      <a:pPr algn="l"/>
+                      <a:r>
+                        <a:rPr sz="1100" b="0">
+                          <a:solidFill>
+                            <a:srgbClr val="1F2A30"/>
+                          </a:solidFill>
+                          <a:latin typeface="Courier New"/>
+                        </a:rPr>
+                        <a:t>CGACTTGCATGTGTTAGGCCTGCCGCCAGCGT</a:t>
+                      </a:r>
+                    </a:p>
+                  </a:txBody>
+                  <a:tcPr marL="73152" marR="73152" marT="18288" marB="18288" anchor="ctr">
+                    <a:solidFill>
+                      <a:srgbClr val="FFFFFF"/>
+                    </a:solidFill>
+                  </a:tcPr>
+                </a:tc>
+                <a:tc>
+                  <a:txBody>
+                    <a:bodyPr wrap="square"/>
+                    <a:lstStyle/>
+                    <a:p>
+                      <a:pPr algn="r"/>
+                      <a:r>
+                        <a:rPr sz="1100" b="0">
+                          <a:solidFill>
+                            <a:srgbClr val="1F2A30"/>
+                          </a:solidFill>
+                          <a:latin typeface="Arial"/>
+                        </a:rPr>
+                        <a:t>9.5%</a:t>
+                      </a:r>
+                    </a:p>
+                  </a:txBody>
+                  <a:tcPr marL="73152" marR="73152" marT="18288" marB="18288" anchor="ctr">
+                    <a:solidFill>
+                      <a:srgbClr val="FFFFFF"/>
+                    </a:solidFill>
+                  </a:tcPr>
+                </a:tc>
+                <a:tc>
+                  <a:txBody>
+                    <a:bodyPr wrap="square"/>
+                    <a:lstStyle/>
+                    <a:p>
+                      <a:pPr algn="r"/>
+                      <a:r>
+                        <a:rPr sz="1100" b="0">
+                          <a:solidFill>
+                            <a:srgbClr val="1F2A30"/>
+                          </a:solidFill>
+                          <a:latin typeface="Arial"/>
+                        </a:rPr>
+                        <a:t>95.3%</a:t>
+                      </a:r>
+                    </a:p>
+                  </a:txBody>
+                  <a:tcPr marL="73152" marR="73152" marT="18288" marB="18288" anchor="ctr">
+                    <a:solidFill>
+                      <a:srgbClr val="FFFFFF"/>
+                    </a:solidFill>
+                  </a:tcPr>
+                </a:tc>
+                <a:tc>
+                  <a:txBody>
+                    <a:bodyPr wrap="square"/>
+                    <a:lstStyle/>
+                    <a:p>
+                      <a:pPr algn="r"/>
+                      <a:r>
+                        <a:rPr sz="1100" b="0">
+                          <a:solidFill>
+                            <a:srgbClr val="1F2A30"/>
+                          </a:solidFill>
+                          <a:latin typeface="Arial"/>
+                        </a:rPr>
+                        <a:t>0</a:t>
+                      </a:r>
+                    </a:p>
+                  </a:txBody>
+                  <a:tcPr marL="73152" marR="73152" marT="18288" marB="18288" anchor="ctr">
+                    <a:solidFill>
+                      <a:srgbClr val="FFFFFF"/>
+                    </a:solidFill>
+                  </a:tcPr>
+                </a:tc>
+                <a:tc>
+                  <a:txBody>
+                    <a:bodyPr wrap="square"/>
+                    <a:lstStyle/>
+                    <a:p>
+                      <a:pPr algn="r"/>
+                      <a:r>
+                        <a:rPr sz="1100" b="0">
+                          <a:solidFill>
+                            <a:srgbClr val="1F2A30"/>
+                          </a:solidFill>
+                          <a:latin typeface="Arial"/>
+                        </a:rPr>
+                        <a:t>1.0000</a:t>
+                      </a:r>
+                    </a:p>
+                  </a:txBody>
+                  <a:tcPr marL="73152" marR="73152" marT="18288" marB="18288" anchor="ctr">
+                    <a:solidFill>
+                      <a:srgbClr val="FFFFFF"/>
+                    </a:solidFill>
+                  </a:tcPr>
+                </a:tc>
+              </a:tr>
+            </a:tbl>
+          </a:graphicData>
+        </a:graphic>
+      </p:graphicFrame>
+      <p:sp>
+        <p:nvSpPr>
+          <p:cNvPr id="7" name="TextBox 6"/>
+          <p:cNvSpPr txBox="1"/>
+          <p:nvPr/>
+        </p:nvSpPr>
+        <p:spPr>
+          <a:xfrm>
+            <a:off x="548640" y="6126480"/>
+            <a:ext cx="11064240" cy="274320"/>
+          </a:xfrm>
+          <a:prstGeom prst="rect">
+            <a:avLst/>
+          </a:prstGeom>
+          <a:noFill/>
+        </p:spPr>
+        <p:txBody>
+          <a:bodyPr wrap="square" anchor="t" lIns="0" rIns="0" tIns="0" bIns="0">
+            <a:spAutoFit/>
+          </a:bodyPr>
+          <a:lstStyle/>
+          <a:p>
+            <a:pPr algn="l">
+              <a:spcAft>
+                <a:spcPts val="0"/>
+              </a:spcAft>
+            </a:pPr>
+            <a:r>
+              <a:rPr sz="1000" b="0" i="0">
+                <a:solidFill>
+                  <a:srgbClr val="5F6B70"/>
+                </a:solidFill>
+                <a:latin typeface="Arial"/>
+              </a:rPr>
+              <a:t>Bold = contains EUB338 (GCTGCCTCCCGTAGGAGT), the classic universal bacterial probe.</a:t>
+            </a:r>
+          </a:p>
+        </p:txBody>
+      </p:sp>
+    </p:spTree>
+  </p:cSld>
+  <p:clrMapOvr>
+    <a:masterClrMapping/>
+  </p:clrMapOvr>
+</p:sld>
+</file>
+
+<file path=ppt/slides/slide14.xml><?xml version="1.0" encoding="utf-8"?>
+<p:sld xmlns:a="http://schemas.openxmlformats.org/drawingml/2006/main" xmlns:p="http://schemas.openxmlformats.org/presentationml/2006/main" xmlns:r="http://schemas.openxmlformats.org/officeDocument/2006/relationships">
+  <p:cSld>
+    <p:bg>
+      <p:bgPr>
+        <a:solidFill>
+          <a:srgbClr val="FFFFFF"/>
+        </a:solidFill>
+        <a:effectLst/>
+      </p:bgPr>
+    </p:bg>
+    <p:spTree>
+      <p:nvGrpSpPr>
+        <p:cNvPr id="1" name=""/>
+        <p:cNvGrpSpPr/>
+        <p:nvPr/>
+      </p:nvGrpSpPr>
+      <p:grpSpPr/>
+      <p:sp>
+        <p:nvSpPr>
+          <p:cNvPr id="2" name="Title"/>
+          <p:cNvSpPr txBox="1"/>
+          <p:nvPr/>
+        </p:nvSpPr>
+        <p:spPr>
+          <a:xfrm>
+            <a:off x="548640" y="384048"/>
+            <a:ext cx="11064240" cy="640080"/>
+          </a:xfrm>
+          <a:prstGeom prst="rect">
+            <a:avLst/>
+          </a:prstGeom>
+          <a:noFill/>
+        </p:spPr>
+        <p:txBody>
+          <a:bodyPr wrap="square" anchor="t" lIns="0" rIns="0" tIns="0" bIns="0">
+            <a:spAutoFit/>
+          </a:bodyPr>
+          <a:lstStyle/>
+          <a:p>
+            <a:pPr algn="l">
+              <a:spcAft>
+                <a:spcPts val="0"/>
+              </a:spcAft>
+            </a:pPr>
+            <a:r>
+              <a:rPr sz="3000" b="1" i="0">
+                <a:solidFill>
+                  <a:srgbClr val="0B3C49"/>
+                </a:solidFill>
+                <a:latin typeface="Arial"/>
+              </a:rPr>
+              <a:t>Validation: 35 external probes, no exact off-targets</a:t>
+            </a:r>
+          </a:p>
+        </p:txBody>
+      </p:sp>
+      <p:sp>
+        <p:nvSpPr>
+          <p:cNvPr id="3" name="Subtitle"/>
+          <p:cNvSpPr txBox="1"/>
+          <p:nvPr/>
+        </p:nvSpPr>
+        <p:spPr>
+          <a:xfrm>
+            <a:off x="548640" y="987552"/>
+            <a:ext cx="11064240" cy="365760"/>
+          </a:xfrm>
+          <a:prstGeom prst="rect">
+            <a:avLst/>
+          </a:prstGeom>
+          <a:noFill/>
+        </p:spPr>
+        <p:txBody>
+          <a:bodyPr wrap="square" anchor="t" lIns="0" rIns="0" tIns="0" bIns="0">
+            <a:spAutoFit/>
+          </a:bodyPr>
+          <a:lstStyle/>
+          <a:p>
+            <a:pPr algn="l">
+              <a:spcAft>
+                <a:spcPts val="0"/>
+              </a:spcAft>
+            </a:pPr>
+            <a:r>
+              <a:rPr sz="1400" b="0" i="0">
+                <a:solidFill>
+                  <a:srgbClr val="5F6B70"/>
+                </a:solidFill>
+                <a:latin typeface="Arial"/>
+              </a:rPr>
+              <a:t>bac-probes validate --blast --exclude-unnamed-congeners on the KAN2M3 query probes (40-mers, 7 species)</a:t>
+            </a:r>
+          </a:p>
+        </p:txBody>
+      </p:sp>
+      <p:sp>
+        <p:nvSpPr>
+          <p:cNvPr id="4" name="TextBox 3"/>
+          <p:cNvSpPr txBox="1"/>
+          <p:nvPr/>
+        </p:nvSpPr>
+        <p:spPr>
+          <a:xfrm>
+            <a:off x="548640" y="6446520"/>
+            <a:ext cx="7315200" cy="228600"/>
+          </a:xfrm>
+          <a:prstGeom prst="rect">
+            <a:avLst/>
+          </a:prstGeom>
+          <a:noFill/>
+        </p:spPr>
+        <p:txBody>
+          <a:bodyPr wrap="square" anchor="t" lIns="0" rIns="0" tIns="0" bIns="0">
+            <a:spAutoFit/>
+          </a:bodyPr>
+          <a:lstStyle/>
+          <a:p>
+            <a:pPr algn="l">
+              <a:spcAft>
+                <a:spcPts val="0"/>
+              </a:spcAft>
+            </a:pPr>
+            <a:r>
+              <a:rPr sz="900" b="0" i="0">
+                <a:solidFill>
+                  <a:srgbClr val="5F6B70"/>
+                </a:solidFill>
+                <a:latin typeface="Arial"/>
+              </a:rPr>
+              <a:t>bac-probes  ·  KAN2M3 probe design</a:t>
+            </a:r>
+          </a:p>
+        </p:txBody>
+      </p:sp>
+      <p:sp>
+        <p:nvSpPr>
+          <p:cNvPr id="5" name="TextBox 4"/>
+          <p:cNvSpPr txBox="1"/>
+          <p:nvPr/>
+        </p:nvSpPr>
+        <p:spPr>
+          <a:xfrm>
+            <a:off x="10725912" y="6446520"/>
+            <a:ext cx="914400" cy="228600"/>
+          </a:xfrm>
+          <a:prstGeom prst="rect">
+            <a:avLst/>
+          </a:prstGeom>
+          <a:noFill/>
+        </p:spPr>
+        <p:txBody>
+          <a:bodyPr wrap="square" anchor="t" lIns="0" rIns="0" tIns="0" bIns="0">
+            <a:spAutoFit/>
+          </a:bodyPr>
+          <a:lstStyle/>
+          <a:p>
+            <a:pPr algn="r">
+              <a:spcAft>
+                <a:spcPts val="0"/>
+              </a:spcAft>
+            </a:pPr>
+            <a:r>
+              <a:rPr sz="900" b="0" i="0">
+                <a:solidFill>
+                  <a:srgbClr val="5F6B70"/>
+                </a:solidFill>
+                <a:latin typeface="Arial"/>
+              </a:rPr>
+              <a:t>14</a:t>
+            </a:r>
+          </a:p>
+        </p:txBody>
+      </p:sp>
+      <p:sp>
+        <p:nvSpPr>
+          <p:cNvPr id="6" name="Rounded Rectangle 5"/>
+          <p:cNvSpPr/>
+          <p:nvPr/>
+        </p:nvSpPr>
+        <p:spPr>
+          <a:xfrm>
+            <a:off x="548640" y="1600200"/>
+            <a:ext cx="3017520" cy="1371600"/>
+          </a:xfrm>
+          <a:prstGeom prst="roundRect">
+            <a:avLst>
+              <a:gd name="adj" fmla="val 8000"/>
+            </a:avLst>
+          </a:prstGeom>
+          <a:solidFill>
+            <a:srgbClr val="DDEFEC"/>
+          </a:solidFill>
+          <a:ln>
+            <a:noFill/>
+          </a:ln>
+          <a:effectLst/>
+        </p:spPr>
+        <p:style>
+          <a:lnRef idx="1">
+            <a:schemeClr val="accent1"/>
+          </a:lnRef>
+          <a:fillRef idx="3">
+            <a:schemeClr val="accent1"/>
+          </a:fillRef>
+          <a:effectRef idx="2">
+            <a:schemeClr val="accent1"/>
+          </a:effectRef>
+          <a:fontRef idx="minor">
+            <a:schemeClr val="lt1"/>
+          </a:fontRef>
+        </p:style>
+        <p:txBody>
+          <a:bodyPr rtlCol="0" anchor="ctr"/>
+          <a:lstStyle/>
+          <a:p>
+            <a:pPr algn="ctr"/>
+          </a:p>
+        </p:txBody>
+      </p:sp>
+      <p:sp>
+        <p:nvSpPr>
+          <p:cNvPr id="7" name="TextBox 6"/>
+          <p:cNvSpPr txBox="1"/>
+          <p:nvPr/>
+        </p:nvSpPr>
+        <p:spPr>
+          <a:xfrm>
+            <a:off x="777240" y="1764792"/>
+            <a:ext cx="2560320" cy="685800"/>
+          </a:xfrm>
+          <a:prstGeom prst="rect">
+            <a:avLst/>
+          </a:prstGeom>
+          <a:noFill/>
+        </p:spPr>
+        <p:txBody>
+          <a:bodyPr wrap="square" anchor="t" lIns="0" rIns="0" tIns="0" bIns="0">
+            <a:spAutoFit/>
+          </a:bodyPr>
+          <a:lstStyle/>
+          <a:p>
+            <a:pPr algn="l">
+              <a:spcAft>
+                <a:spcPts val="0"/>
+              </a:spcAft>
+            </a:pPr>
+            <a:r>
+              <a:rPr sz="3600" b="1" i="0">
+                <a:solidFill>
+                  <a:srgbClr val="0B3C49"/>
+                </a:solidFill>
+                <a:latin typeface="Arial"/>
+              </a:rPr>
+              <a:t>0</a:t>
+            </a:r>
+          </a:p>
+        </p:txBody>
+      </p:sp>
+      <p:sp>
+        <p:nvSpPr>
+          <p:cNvPr id="8" name="TextBox 7"/>
+          <p:cNvSpPr txBox="1"/>
+          <p:nvPr/>
+        </p:nvSpPr>
+        <p:spPr>
+          <a:xfrm>
+            <a:off x="777240" y="2468880"/>
+            <a:ext cx="2560320" cy="411479"/>
+          </a:xfrm>
+          <a:prstGeom prst="rect">
+            <a:avLst/>
+          </a:prstGeom>
+          <a:noFill/>
+        </p:spPr>
+        <p:txBody>
+          <a:bodyPr wrap="square" anchor="t" lIns="0" rIns="0" tIns="0" bIns="0">
+            <a:spAutoFit/>
+          </a:bodyPr>
+          <a:lstStyle/>
+          <a:p>
+            <a:pPr algn="l">
+              <a:spcAft>
+                <a:spcPts val="0"/>
+              </a:spcAft>
+            </a:pPr>
+            <a:r>
+              <a:rPr sz="1200" b="0" i="0">
+                <a:solidFill>
+                  <a:srgbClr val="1F2A30"/>
+                </a:solidFill>
+                <a:latin typeface="Arial"/>
+              </a:rPr>
+              <a:t>exact off-target matches across all 35 probes</a:t>
+            </a:r>
+          </a:p>
+        </p:txBody>
+      </p:sp>
+      <p:sp>
+        <p:nvSpPr>
+          <p:cNvPr id="9" name="Rounded Rectangle 8"/>
+          <p:cNvSpPr/>
+          <p:nvPr/>
+        </p:nvSpPr>
+        <p:spPr>
+          <a:xfrm>
+            <a:off x="548640" y="3154680"/>
+            <a:ext cx="3017520" cy="1371600"/>
+          </a:xfrm>
+          <a:prstGeom prst="roundRect">
+            <a:avLst>
+              <a:gd name="adj" fmla="val 8000"/>
+            </a:avLst>
+          </a:prstGeom>
+          <a:solidFill>
+            <a:srgbClr val="DDEFEC"/>
+          </a:solidFill>
+          <a:ln>
+            <a:noFill/>
+          </a:ln>
+          <a:effectLst/>
+        </p:spPr>
+        <p:style>
+          <a:lnRef idx="1">
+            <a:schemeClr val="accent1"/>
+          </a:lnRef>
+          <a:fillRef idx="3">
+            <a:schemeClr val="accent1"/>
+          </a:fillRef>
+          <a:effectRef idx="2">
+            <a:schemeClr val="accent1"/>
+          </a:effectRef>
+          <a:fontRef idx="minor">
+            <a:schemeClr val="lt1"/>
+          </a:fontRef>
+        </p:style>
+        <p:txBody>
+          <a:bodyPr rtlCol="0" anchor="ctr"/>
+          <a:lstStyle/>
+          <a:p>
+            <a:pPr algn="ctr"/>
+          </a:p>
+        </p:txBody>
+      </p:sp>
+      <p:sp>
+        <p:nvSpPr>
+          <p:cNvPr id="10" name="TextBox 9"/>
+          <p:cNvSpPr txBox="1"/>
+          <p:nvPr/>
+        </p:nvSpPr>
+        <p:spPr>
+          <a:xfrm>
+            <a:off x="777240" y="3319272"/>
+            <a:ext cx="2560320" cy="685800"/>
+          </a:xfrm>
+          <a:prstGeom prst="rect">
+            <a:avLst/>
+          </a:prstGeom>
+          <a:noFill/>
+        </p:spPr>
+        <p:txBody>
+          <a:bodyPr wrap="square" anchor="t" lIns="0" rIns="0" tIns="0" bIns="0">
+            <a:spAutoFit/>
+          </a:bodyPr>
+          <a:lstStyle/>
+          <a:p>
+            <a:pPr algn="l">
+              <a:spcAft>
+                <a:spcPts val="0"/>
+              </a:spcAft>
+            </a:pPr>
+            <a:r>
+              <a:rPr sz="3600" b="1" i="0">
+                <a:solidFill>
+                  <a:srgbClr val="F0634F"/>
+                </a:solidFill>
+                <a:latin typeface="Arial"/>
+              </a:rPr>
+              <a:t>31 / 35</a:t>
+            </a:r>
+          </a:p>
+        </p:txBody>
+      </p:sp>
+      <p:sp>
+        <p:nvSpPr>
+          <p:cNvPr id="11" name="TextBox 10"/>
+          <p:cNvSpPr txBox="1"/>
+          <p:nvPr/>
+        </p:nvSpPr>
+        <p:spPr>
+          <a:xfrm>
+            <a:off x="777240" y="4023360"/>
+            <a:ext cx="2560320" cy="411479"/>
+          </a:xfrm>
+          <a:prstGeom prst="rect">
+            <a:avLst/>
+          </a:prstGeom>
+          <a:noFill/>
+        </p:spPr>
+        <p:txBody>
+          <a:bodyPr wrap="square" anchor="t" lIns="0" rIns="0" tIns="0" bIns="0">
+            <a:spAutoFit/>
+          </a:bodyPr>
+          <a:lstStyle/>
+          <a:p>
+            <a:pPr algn="l">
+              <a:spcAft>
+                <a:spcPts val="0"/>
+              </a:spcAft>
+            </a:pPr>
+            <a:r>
+              <a:rPr sz="1200" b="0" i="0">
+                <a:solidFill>
+                  <a:srgbClr val="1F2A30"/>
+                </a:solidFill>
+                <a:latin typeface="Arial"/>
+              </a:rPr>
+              <a:t>probes exactly match &lt; 5% of their species</a:t>
+            </a:r>
+          </a:p>
+        </p:txBody>
+      </p:sp>
+      <p:sp>
+        <p:nvSpPr>
+          <p:cNvPr id="12" name="Rounded Rectangle 11"/>
+          <p:cNvSpPr/>
+          <p:nvPr/>
+        </p:nvSpPr>
+        <p:spPr>
+          <a:xfrm>
+            <a:off x="548640" y="4709160"/>
+            <a:ext cx="3017520" cy="1371600"/>
+          </a:xfrm>
+          <a:prstGeom prst="roundRect">
+            <a:avLst>
+              <a:gd name="adj" fmla="val 8000"/>
+            </a:avLst>
+          </a:prstGeom>
+          <a:solidFill>
+            <a:srgbClr val="DDEFEC"/>
+          </a:solidFill>
+          <a:ln>
+            <a:noFill/>
+          </a:ln>
+          <a:effectLst/>
+        </p:spPr>
+        <p:style>
+          <a:lnRef idx="1">
+            <a:schemeClr val="accent1"/>
+          </a:lnRef>
+          <a:fillRef idx="3">
+            <a:schemeClr val="accent1"/>
+          </a:fillRef>
+          <a:effectRef idx="2">
+            <a:schemeClr val="accent1"/>
+          </a:effectRef>
+          <a:fontRef idx="minor">
+            <a:schemeClr val="lt1"/>
+          </a:fontRef>
+        </p:style>
+        <p:txBody>
+          <a:bodyPr rtlCol="0" anchor="ctr"/>
+          <a:lstStyle/>
+          <a:p>
+            <a:pPr algn="ctr"/>
+          </a:p>
+        </p:txBody>
+      </p:sp>
+      <p:sp>
+        <p:nvSpPr>
+          <p:cNvPr id="13" name="TextBox 12"/>
+          <p:cNvSpPr txBox="1"/>
+          <p:nvPr/>
+        </p:nvSpPr>
+        <p:spPr>
+          <a:xfrm>
+            <a:off x="777240" y="4873752"/>
+            <a:ext cx="2560320" cy="685800"/>
+          </a:xfrm>
+          <a:prstGeom prst="rect">
+            <a:avLst/>
+          </a:prstGeom>
+          <a:noFill/>
+        </p:spPr>
+        <p:txBody>
+          <a:bodyPr wrap="square" anchor="t" lIns="0" rIns="0" tIns="0" bIns="0">
+            <a:spAutoFit/>
+          </a:bodyPr>
+          <a:lstStyle/>
+          <a:p>
+            <a:pPr algn="l">
+              <a:spcAft>
+                <a:spcPts val="0"/>
+              </a:spcAft>
+            </a:pPr>
+            <a:r>
+              <a:rPr sz="3600" b="1" i="0">
+                <a:solidFill>
+                  <a:srgbClr val="0B3C49"/>
+                </a:solidFill>
+                <a:latin typeface="Arial"/>
+              </a:rPr>
               <a:t>18 / 35</a:t>
             </a:r>
           </a:p>
@@ -9618,7 +13524,7 @@
 </p:sld>
 </file>
 
-<file path=ppt/slides/slide13.xml><?xml version="1.0" encoding="utf-8"?>
+<file path=ppt/slides/slide15.xml><?xml version="1.0" encoding="utf-8"?>
 <p:sld xmlns:a="http://schemas.openxmlformats.org/drawingml/2006/main" xmlns:p="http://schemas.openxmlformats.org/presentationml/2006/main" xmlns:r="http://schemas.openxmlformats.org/officeDocument/2006/relationships">
   <p:cSld>
     <p:bg>
@@ -9787,7 +13693,7 @@
                 </a:solidFill>
                 <a:latin typeface="Arial"/>
               </a:rPr>
-              <a:t>13</a:t>
+              <a:t>15</a:t>
             </a:r>
           </a:p>
         </p:txBody>

</xml_diff>